<commit_message>
Updating to better handle EVIMO data
</commit_message>
<xml_diff>
--- a/SNN.pptx
+++ b/SNN.pptx
@@ -260,7 +260,7 @@
           <a:p>
             <a:fld id="{18514EC9-E150-4B7A-9B8E-2980A974DF62}" type="datetimeFigureOut">
               <a:rPr lang="en-US" smtClean="0"/>
-              <a:t>10/16/2023</a:t>
+              <a:t>10/17/2023</a:t>
             </a:fld>
             <a:endParaRPr lang="en-US"/>
           </a:p>
@@ -458,7 +458,7 @@
           <a:p>
             <a:fld id="{18514EC9-E150-4B7A-9B8E-2980A974DF62}" type="datetimeFigureOut">
               <a:rPr lang="en-US" smtClean="0"/>
-              <a:t>10/16/2023</a:t>
+              <a:t>10/17/2023</a:t>
             </a:fld>
             <a:endParaRPr lang="en-US"/>
           </a:p>
@@ -666,7 +666,7 @@
           <a:p>
             <a:fld id="{18514EC9-E150-4B7A-9B8E-2980A974DF62}" type="datetimeFigureOut">
               <a:rPr lang="en-US" smtClean="0"/>
-              <a:t>10/16/2023</a:t>
+              <a:t>10/17/2023</a:t>
             </a:fld>
             <a:endParaRPr lang="en-US"/>
           </a:p>
@@ -864,7 +864,7 @@
           <a:p>
             <a:fld id="{18514EC9-E150-4B7A-9B8E-2980A974DF62}" type="datetimeFigureOut">
               <a:rPr lang="en-US" smtClean="0"/>
-              <a:t>10/16/2023</a:t>
+              <a:t>10/17/2023</a:t>
             </a:fld>
             <a:endParaRPr lang="en-US"/>
           </a:p>
@@ -1139,7 +1139,7 @@
           <a:p>
             <a:fld id="{18514EC9-E150-4B7A-9B8E-2980A974DF62}" type="datetimeFigureOut">
               <a:rPr lang="en-US" smtClean="0"/>
-              <a:t>10/16/2023</a:t>
+              <a:t>10/17/2023</a:t>
             </a:fld>
             <a:endParaRPr lang="en-US"/>
           </a:p>
@@ -1404,7 +1404,7 @@
           <a:p>
             <a:fld id="{18514EC9-E150-4B7A-9B8E-2980A974DF62}" type="datetimeFigureOut">
               <a:rPr lang="en-US" smtClean="0"/>
-              <a:t>10/16/2023</a:t>
+              <a:t>10/17/2023</a:t>
             </a:fld>
             <a:endParaRPr lang="en-US"/>
           </a:p>
@@ -1816,7 +1816,7 @@
           <a:p>
             <a:fld id="{18514EC9-E150-4B7A-9B8E-2980A974DF62}" type="datetimeFigureOut">
               <a:rPr lang="en-US" smtClean="0"/>
-              <a:t>10/16/2023</a:t>
+              <a:t>10/17/2023</a:t>
             </a:fld>
             <a:endParaRPr lang="en-US"/>
           </a:p>
@@ -1957,7 +1957,7 @@
           <a:p>
             <a:fld id="{18514EC9-E150-4B7A-9B8E-2980A974DF62}" type="datetimeFigureOut">
               <a:rPr lang="en-US" smtClean="0"/>
-              <a:t>10/16/2023</a:t>
+              <a:t>10/17/2023</a:t>
             </a:fld>
             <a:endParaRPr lang="en-US"/>
           </a:p>
@@ -2070,7 +2070,7 @@
           <a:p>
             <a:fld id="{18514EC9-E150-4B7A-9B8E-2980A974DF62}" type="datetimeFigureOut">
               <a:rPr lang="en-US" smtClean="0"/>
-              <a:t>10/16/2023</a:t>
+              <a:t>10/17/2023</a:t>
             </a:fld>
             <a:endParaRPr lang="en-US"/>
           </a:p>
@@ -2381,7 +2381,7 @@
           <a:p>
             <a:fld id="{18514EC9-E150-4B7A-9B8E-2980A974DF62}" type="datetimeFigureOut">
               <a:rPr lang="en-US" smtClean="0"/>
-              <a:t>10/16/2023</a:t>
+              <a:t>10/17/2023</a:t>
             </a:fld>
             <a:endParaRPr lang="en-US"/>
           </a:p>
@@ -2669,7 +2669,7 @@
           <a:p>
             <a:fld id="{18514EC9-E150-4B7A-9B8E-2980A974DF62}" type="datetimeFigureOut">
               <a:rPr lang="en-US" smtClean="0"/>
-              <a:t>10/16/2023</a:t>
+              <a:t>10/17/2023</a:t>
             </a:fld>
             <a:endParaRPr lang="en-US"/>
           </a:p>
@@ -2910,7 +2910,7 @@
           <a:p>
             <a:fld id="{18514EC9-E150-4B7A-9B8E-2980A974DF62}" type="datetimeFigureOut">
               <a:rPr lang="en-US" smtClean="0"/>
-              <a:t>10/16/2023</a:t>
+              <a:t>10/17/2023</a:t>
             </a:fld>
             <a:endParaRPr lang="en-US"/>
           </a:p>
@@ -3895,34 +3895,13 @@
         </p:spPr>
         <p:txBody>
           <a:bodyPr>
-            <a:normAutofit fontScale="92500" lnSpcReduction="20000"/>
+            <a:normAutofit lnSpcReduction="10000"/>
           </a:bodyPr>
           <a:lstStyle/>
           <a:p>
             <a:r>
               <a:rPr lang="en-US" sz="1600" dirty="0"/>
-              <a:t>Expand training data</a:t>
-            </a:r>
-          </a:p>
-          <a:p>
-            <a:pPr lvl="1"/>
-            <a:r>
-              <a:rPr lang="en-US" sz="1200" dirty="0"/>
-              <a:t>Only training on 418 bins currently</a:t>
-            </a:r>
-          </a:p>
-          <a:p>
-            <a:pPr lvl="1"/>
-            <a:r>
-              <a:rPr lang="en-US" sz="1200" dirty="0"/>
-              <a:t>May generate masks at higher rates so that we can have more bins per sequence</a:t>
-            </a:r>
-          </a:p>
-          <a:p>
-            <a:pPr lvl="1"/>
-            <a:r>
-              <a:rPr lang="en-US" sz="1200" dirty="0"/>
-              <a:t>Pull in more sequences of EVIMO data</a:t>
+              <a:t>Expand/shrink training data</a:t>
             </a:r>
           </a:p>
           <a:p>
@@ -3934,25 +3913,32 @@
           <a:p>
             <a:r>
               <a:rPr lang="en-US" sz="1600" dirty="0"/>
-              <a:t>Sanity check with different </a:t>
+              <a:t>Train on if there is any object, instead of a specific one</a:t>
+            </a:r>
+          </a:p>
+          <a:p>
+            <a:r>
+              <a:rPr lang="en-US" sz="1600" dirty="0"/>
+              <a:t>Get first x </a:t>
             </a:r>
             <a:r>
               <a:rPr lang="en-US" sz="1600" dirty="0" err="1"/>
-              <a:t>PyTorch</a:t>
+              <a:t>ms</a:t>
             </a:r>
             <a:r>
               <a:rPr lang="en-US" sz="1600" dirty="0"/>
-              <a:t> model</a:t>
-            </a:r>
-          </a:p>
-          <a:p>
-            <a:pPr lvl="1"/>
-            <a:r>
-              <a:rPr lang="en-US" sz="1200" dirty="0"/>
-              <a:t>Ensure I am preprocessing data correctly</a:t>
-            </a:r>
-          </a:p>
-          <a:p>
+              <a:t> of data from each bin/sequence, </a:t>
+            </a:r>
+            <a:r>
+              <a:rPr lang="en-US" sz="1600"/>
+              <a:t>use that</a:t>
+            </a:r>
+            <a:endParaRPr lang="en-US" sz="1600" dirty="0"/>
+          </a:p>
+          <a:p>
+            <a:pPr marL="0" indent="0">
+              <a:buNone/>
+            </a:pPr>
             <a:endParaRPr lang="en-US" sz="1600" dirty="0"/>
           </a:p>
         </p:txBody>

</xml_diff>

<commit_message>
Updates from this week
</commit_message>
<xml_diff>
--- a/SNN.pptx
+++ b/SNN.pptx
@@ -260,7 +260,7 @@
           <a:p>
             <a:fld id="{18514EC9-E150-4B7A-9B8E-2980A974DF62}" type="datetimeFigureOut">
               <a:rPr lang="en-US" smtClean="0"/>
-              <a:t>10/17/2023</a:t>
+              <a:t>10/23/2023</a:t>
             </a:fld>
             <a:endParaRPr lang="en-US"/>
           </a:p>
@@ -458,7 +458,7 @@
           <a:p>
             <a:fld id="{18514EC9-E150-4B7A-9B8E-2980A974DF62}" type="datetimeFigureOut">
               <a:rPr lang="en-US" smtClean="0"/>
-              <a:t>10/17/2023</a:t>
+              <a:t>10/23/2023</a:t>
             </a:fld>
             <a:endParaRPr lang="en-US"/>
           </a:p>
@@ -666,7 +666,7 @@
           <a:p>
             <a:fld id="{18514EC9-E150-4B7A-9B8E-2980A974DF62}" type="datetimeFigureOut">
               <a:rPr lang="en-US" smtClean="0"/>
-              <a:t>10/17/2023</a:t>
+              <a:t>10/23/2023</a:t>
             </a:fld>
             <a:endParaRPr lang="en-US"/>
           </a:p>
@@ -864,7 +864,7 @@
           <a:p>
             <a:fld id="{18514EC9-E150-4B7A-9B8E-2980A974DF62}" type="datetimeFigureOut">
               <a:rPr lang="en-US" smtClean="0"/>
-              <a:t>10/17/2023</a:t>
+              <a:t>10/23/2023</a:t>
             </a:fld>
             <a:endParaRPr lang="en-US"/>
           </a:p>
@@ -1139,7 +1139,7 @@
           <a:p>
             <a:fld id="{18514EC9-E150-4B7A-9B8E-2980A974DF62}" type="datetimeFigureOut">
               <a:rPr lang="en-US" smtClean="0"/>
-              <a:t>10/17/2023</a:t>
+              <a:t>10/23/2023</a:t>
             </a:fld>
             <a:endParaRPr lang="en-US"/>
           </a:p>
@@ -1404,7 +1404,7 @@
           <a:p>
             <a:fld id="{18514EC9-E150-4B7A-9B8E-2980A974DF62}" type="datetimeFigureOut">
               <a:rPr lang="en-US" smtClean="0"/>
-              <a:t>10/17/2023</a:t>
+              <a:t>10/23/2023</a:t>
             </a:fld>
             <a:endParaRPr lang="en-US"/>
           </a:p>
@@ -1816,7 +1816,7 @@
           <a:p>
             <a:fld id="{18514EC9-E150-4B7A-9B8E-2980A974DF62}" type="datetimeFigureOut">
               <a:rPr lang="en-US" smtClean="0"/>
-              <a:t>10/17/2023</a:t>
+              <a:t>10/23/2023</a:t>
             </a:fld>
             <a:endParaRPr lang="en-US"/>
           </a:p>
@@ -1957,7 +1957,7 @@
           <a:p>
             <a:fld id="{18514EC9-E150-4B7A-9B8E-2980A974DF62}" type="datetimeFigureOut">
               <a:rPr lang="en-US" smtClean="0"/>
-              <a:t>10/17/2023</a:t>
+              <a:t>10/23/2023</a:t>
             </a:fld>
             <a:endParaRPr lang="en-US"/>
           </a:p>
@@ -2070,7 +2070,7 @@
           <a:p>
             <a:fld id="{18514EC9-E150-4B7A-9B8E-2980A974DF62}" type="datetimeFigureOut">
               <a:rPr lang="en-US" smtClean="0"/>
-              <a:t>10/17/2023</a:t>
+              <a:t>10/23/2023</a:t>
             </a:fld>
             <a:endParaRPr lang="en-US"/>
           </a:p>
@@ -2381,7 +2381,7 @@
           <a:p>
             <a:fld id="{18514EC9-E150-4B7A-9B8E-2980A974DF62}" type="datetimeFigureOut">
               <a:rPr lang="en-US" smtClean="0"/>
-              <a:t>10/17/2023</a:t>
+              <a:t>10/23/2023</a:t>
             </a:fld>
             <a:endParaRPr lang="en-US"/>
           </a:p>
@@ -2669,7 +2669,7 @@
           <a:p>
             <a:fld id="{18514EC9-E150-4B7A-9B8E-2980A974DF62}" type="datetimeFigureOut">
               <a:rPr lang="en-US" smtClean="0"/>
-              <a:t>10/17/2023</a:t>
+              <a:t>10/23/2023</a:t>
             </a:fld>
             <a:endParaRPr lang="en-US"/>
           </a:p>
@@ -2910,7 +2910,7 @@
           <a:p>
             <a:fld id="{18514EC9-E150-4B7A-9B8E-2980A974DF62}" type="datetimeFigureOut">
               <a:rPr lang="en-US" smtClean="0"/>
-              <a:t>10/17/2023</a:t>
+              <a:t>10/23/2023</a:t>
             </a:fld>
             <a:endParaRPr lang="en-US"/>
           </a:p>
@@ -3353,7 +3353,7 @@
             <a:pPr algn="ctr"/>
             <a:r>
               <a:rPr lang="en-US" sz="3200" dirty="0"/>
-              <a:t>EVIMO For Image Classification</a:t>
+              <a:t>Last Week: EVIMO For Image Classification</a:t>
             </a:r>
           </a:p>
         </p:txBody>
@@ -3377,7 +3377,7 @@
         <p:spPr>
           <a:xfrm>
             <a:off x="752258" y="1690687"/>
-            <a:ext cx="4057651" cy="3008499"/>
+            <a:ext cx="4286147" cy="3008499"/>
           </a:xfrm>
         </p:spPr>
         <p:txBody>
@@ -3415,10 +3415,7 @@
           </a:p>
           <a:p>
             <a:pPr lvl="1"/>
-            <a:r>
-              <a:rPr lang="en-US" sz="1600" dirty="0"/>
-              <a:t>Trimmed off first 285 bins to have equal number of labels</a:t>
-            </a:r>
+            <a:endParaRPr lang="en-US" sz="1200" dirty="0"/>
           </a:p>
           <a:p>
             <a:pPr marL="0" indent="0">
@@ -3866,17 +3863,17 @@
             <a:pPr algn="ctr"/>
             <a:r>
               <a:rPr lang="en-US" sz="3200" dirty="0"/>
-              <a:t>Next Steps</a:t>
-            </a:r>
-          </a:p>
-        </p:txBody>
-      </p:sp>
-      <p:sp>
-        <p:nvSpPr>
-          <p:cNvPr id="3" name="Content Placeholder 2">
-            <a:extLst>
-              <a:ext uri="{FF2B5EF4-FFF2-40B4-BE49-F238E27FC236}">
-                <a16:creationId xmlns:a16="http://schemas.microsoft.com/office/drawing/2014/main" id="{0306A38B-9CFD-515B-1ED6-79E0C41D8E1E}"/>
+              <a:t>This Week</a:t>
+            </a:r>
+          </a:p>
+        </p:txBody>
+      </p:sp>
+      <p:sp>
+        <p:nvSpPr>
+          <p:cNvPr id="6" name="Content Placeholder 5">
+            <a:extLst>
+              <a:ext uri="{FF2B5EF4-FFF2-40B4-BE49-F238E27FC236}">
+                <a16:creationId xmlns:a16="http://schemas.microsoft.com/office/drawing/2014/main" id="{9FB6687C-7EDE-40C1-AF3F-BA73585DCAA5}"/>
               </a:ext>
             </a:extLst>
           </p:cNvPr>
@@ -3889,66 +3886,104 @@
         </p:nvSpPr>
         <p:spPr>
           <a:xfrm>
-            <a:off x="752258" y="1690687"/>
-            <a:ext cx="4132725" cy="1788943"/>
+            <a:off x="838199" y="1825625"/>
+            <a:ext cx="4421136" cy="2727964"/>
           </a:xfrm>
         </p:spPr>
         <p:txBody>
           <a:bodyPr>
-            <a:normAutofit lnSpcReduction="10000"/>
+            <a:normAutofit fontScale="70000" lnSpcReduction="20000"/>
           </a:bodyPr>
           <a:lstStyle/>
           <a:p>
             <a:r>
-              <a:rPr lang="en-US" sz="1600" dirty="0"/>
-              <a:t>Expand/shrink training data</a:t>
-            </a:r>
-          </a:p>
-          <a:p>
-            <a:r>
-              <a:rPr lang="en-US" sz="1600" dirty="0"/>
-              <a:t>Increase learning rate</a:t>
-            </a:r>
-          </a:p>
-          <a:p>
-            <a:r>
-              <a:rPr lang="en-US" sz="1600" dirty="0"/>
-              <a:t>Train on if there is any object, instead of a specific one</a:t>
-            </a:r>
-          </a:p>
-          <a:p>
-            <a:r>
-              <a:rPr lang="en-US" sz="1600" dirty="0"/>
-              <a:t>Get first x </a:t>
-            </a:r>
-            <a:r>
-              <a:rPr lang="en-US" sz="1600" dirty="0" err="1"/>
-              <a:t>ms</a:t>
-            </a:r>
-            <a:r>
-              <a:rPr lang="en-US" sz="1600" dirty="0"/>
-              <a:t> of data from each bin/sequence, </a:t>
-            </a:r>
-            <a:r>
-              <a:rPr lang="en-US" sz="1600"/>
-              <a:t>use that</a:t>
-            </a:r>
-            <a:endParaRPr lang="en-US" sz="1600" dirty="0"/>
-          </a:p>
-          <a:p>
-            <a:pPr marL="0" indent="0">
-              <a:buNone/>
-            </a:pPr>
-            <a:endParaRPr lang="en-US" sz="1600" dirty="0"/>
+              <a:rPr lang="en-US" sz="2200" dirty="0"/>
+              <a:t>Further modified EVIMO data for input into model</a:t>
+            </a:r>
+          </a:p>
+          <a:p>
+            <a:pPr lvl="1"/>
+            <a:r>
+              <a:rPr lang="en-US" sz="1800" dirty="0"/>
+              <a:t>Splitting each frame into bins</a:t>
+            </a:r>
+          </a:p>
+          <a:p>
+            <a:pPr lvl="1"/>
+            <a:r>
+              <a:rPr lang="en-US" sz="1800" dirty="0"/>
+              <a:t>EVIMO now of format: </a:t>
+            </a:r>
+            <a:br>
+              <a:rPr lang="en-US" sz="1800" dirty="0"/>
+            </a:br>
+            <a:r>
+              <a:rPr lang="en-US" sz="1800" dirty="0"/>
+              <a:t>(Frames/batch size, Bins per frame, p, x, y)</a:t>
+            </a:r>
+          </a:p>
+          <a:p>
+            <a:pPr lvl="1"/>
+            <a:r>
+              <a:rPr lang="en-US" sz="1800" dirty="0"/>
+              <a:t>NMNIST data of format:</a:t>
+            </a:r>
+            <a:br>
+              <a:rPr lang="en-US" sz="1800" dirty="0"/>
+            </a:br>
+            <a:r>
+              <a:rPr lang="en-US" sz="1800" dirty="0"/>
+              <a:t>(T, batch size, p, x, y)</a:t>
+            </a:r>
+          </a:p>
+          <a:p>
+            <a:r>
+              <a:rPr lang="en-US" sz="2200" dirty="0"/>
+              <a:t>Fixed alignment of frames in dataset</a:t>
+            </a:r>
+            <a:endParaRPr lang="en-US" sz="1800" dirty="0"/>
+          </a:p>
+          <a:p>
+            <a:pPr lvl="1"/>
+            <a:r>
+              <a:rPr lang="en-US" sz="1800" dirty="0"/>
+              <a:t>EVIMO frames are not all same length</a:t>
+            </a:r>
+          </a:p>
+          <a:p>
+            <a:r>
+              <a:rPr lang="en-US" sz="2200" dirty="0"/>
+              <a:t>Set up test dataset</a:t>
+            </a:r>
+          </a:p>
+          <a:p>
+            <a:pPr lvl="1"/>
+            <a:r>
+              <a:rPr lang="en-US" sz="1800" dirty="0"/>
+              <a:t>50% all 0’s, 50% all 1’s</a:t>
+            </a:r>
+          </a:p>
+          <a:p>
+            <a:r>
+              <a:rPr lang="en-US" sz="2200" dirty="0"/>
+              <a:t>Model accuracy still not improving</a:t>
+            </a:r>
+          </a:p>
+          <a:p>
+            <a:pPr lvl="1"/>
+            <a:r>
+              <a:rPr lang="en-US" sz="1800" dirty="0"/>
+              <a:t>Highest accuracy ~55%</a:t>
+            </a:r>
           </a:p>
         </p:txBody>
       </p:sp>
       <p:pic>
         <p:nvPicPr>
-          <p:cNvPr id="10" name="Picture 9">
-            <a:extLst>
-              <a:ext uri="{FF2B5EF4-FFF2-40B4-BE49-F238E27FC236}">
-                <a16:creationId xmlns:a16="http://schemas.microsoft.com/office/drawing/2014/main" id="{B4F8569D-BD80-F9DB-FD30-90E3AEA0AB28}"/>
+          <p:cNvPr id="8" name="Picture 7">
+            <a:extLst>
+              <a:ext uri="{FF2B5EF4-FFF2-40B4-BE49-F238E27FC236}">
+                <a16:creationId xmlns:a16="http://schemas.microsoft.com/office/drawing/2014/main" id="{5F621548-74E9-AD5D-08EF-B2324E5DAE05}"/>
               </a:ext>
             </a:extLst>
           </p:cNvPr>
@@ -3965,98 +4000,8 @@
         </p:blipFill>
         <p:spPr>
           <a:xfrm>
-            <a:off x="838200" y="4185397"/>
-            <a:ext cx="3970941" cy="1664995"/>
-          </a:xfrm>
-          <a:prstGeom prst="rect">
-            <a:avLst/>
-          </a:prstGeom>
-        </p:spPr>
-      </p:pic>
-      <p:pic>
-        <p:nvPicPr>
-          <p:cNvPr id="5" name="Picture 4">
-            <a:extLst>
-              <a:ext uri="{FF2B5EF4-FFF2-40B4-BE49-F238E27FC236}">
-                <a16:creationId xmlns:a16="http://schemas.microsoft.com/office/drawing/2014/main" id="{9BDEC7C8-258A-A1AB-810D-349973699F0B}"/>
-              </a:ext>
-            </a:extLst>
-          </p:cNvPr>
-          <p:cNvPicPr>
-            <a:picLocks noChangeAspect="1"/>
-          </p:cNvPicPr>
-          <p:nvPr/>
-        </p:nvPicPr>
-        <p:blipFill>
-          <a:blip r:embed="rId3"/>
-          <a:stretch>
-            <a:fillRect/>
-          </a:stretch>
-        </p:blipFill>
-        <p:spPr>
-          <a:xfrm>
-            <a:off x="5633080" y="4209784"/>
-            <a:ext cx="1787388" cy="957529"/>
-          </a:xfrm>
-          <a:prstGeom prst="rect">
-            <a:avLst/>
-          </a:prstGeom>
-        </p:spPr>
-      </p:pic>
-      <p:pic>
-        <p:nvPicPr>
-          <p:cNvPr id="11" name="Picture 10">
-            <a:extLst>
-              <a:ext uri="{FF2B5EF4-FFF2-40B4-BE49-F238E27FC236}">
-                <a16:creationId xmlns:a16="http://schemas.microsoft.com/office/drawing/2014/main" id="{43762509-D31E-09DA-C5DD-2AEF5725786B}"/>
-              </a:ext>
-            </a:extLst>
-          </p:cNvPr>
-          <p:cNvPicPr>
-            <a:picLocks noChangeAspect="1"/>
-          </p:cNvPicPr>
-          <p:nvPr/>
-        </p:nvPicPr>
-        <p:blipFill>
-          <a:blip r:embed="rId4"/>
-          <a:stretch>
-            <a:fillRect/>
-          </a:stretch>
-        </p:blipFill>
-        <p:spPr>
-          <a:xfrm>
-            <a:off x="5653340" y="5387643"/>
-            <a:ext cx="2579930" cy="925498"/>
-          </a:xfrm>
-          <a:prstGeom prst="rect">
-            <a:avLst/>
-          </a:prstGeom>
-        </p:spPr>
-      </p:pic>
-      <p:pic>
-        <p:nvPicPr>
-          <p:cNvPr id="15" name="Picture 14">
-            <a:extLst>
-              <a:ext uri="{FF2B5EF4-FFF2-40B4-BE49-F238E27FC236}">
-                <a16:creationId xmlns:a16="http://schemas.microsoft.com/office/drawing/2014/main" id="{B14E0AEC-0F4B-3C7A-9D4E-FB962D2B4889}"/>
-              </a:ext>
-            </a:extLst>
-          </p:cNvPr>
-          <p:cNvPicPr>
-            <a:picLocks noChangeAspect="1"/>
-          </p:cNvPicPr>
-          <p:nvPr/>
-        </p:nvPicPr>
-        <p:blipFill>
-          <a:blip r:embed="rId5"/>
-          <a:stretch>
-            <a:fillRect/>
-          </a:stretch>
-        </p:blipFill>
-        <p:spPr>
-          <a:xfrm>
-            <a:off x="8395054" y="2421656"/>
-            <a:ext cx="3660914" cy="3826317"/>
+            <a:off x="5613898" y="3551738"/>
+            <a:ext cx="6481958" cy="928391"/>
           </a:xfrm>
           <a:prstGeom prst="rect">
             <a:avLst/>

</xml_diff>

<commit_message>
Pushing updates for 10/31 meeting
</commit_message>
<xml_diff>
--- a/SNN.pptx
+++ b/SNN.pptx
@@ -7,6 +7,7 @@
   <p:sldIdLst>
     <p:sldId id="257" r:id="rId2"/>
     <p:sldId id="259" r:id="rId3"/>
+    <p:sldId id="260" r:id="rId4"/>
   </p:sldIdLst>
   <p:sldSz cx="12192000" cy="6858000"/>
   <p:notesSz cx="6858000" cy="9144000"/>
@@ -260,7 +261,7 @@
           <a:p>
             <a:fld id="{18514EC9-E150-4B7A-9B8E-2980A974DF62}" type="datetimeFigureOut">
               <a:rPr lang="en-US" smtClean="0"/>
-              <a:t>10/23/2023</a:t>
+              <a:t>10/30/2023</a:t>
             </a:fld>
             <a:endParaRPr lang="en-US"/>
           </a:p>
@@ -458,7 +459,7 @@
           <a:p>
             <a:fld id="{18514EC9-E150-4B7A-9B8E-2980A974DF62}" type="datetimeFigureOut">
               <a:rPr lang="en-US" smtClean="0"/>
-              <a:t>10/23/2023</a:t>
+              <a:t>10/30/2023</a:t>
             </a:fld>
             <a:endParaRPr lang="en-US"/>
           </a:p>
@@ -666,7 +667,7 @@
           <a:p>
             <a:fld id="{18514EC9-E150-4B7A-9B8E-2980A974DF62}" type="datetimeFigureOut">
               <a:rPr lang="en-US" smtClean="0"/>
-              <a:t>10/23/2023</a:t>
+              <a:t>10/30/2023</a:t>
             </a:fld>
             <a:endParaRPr lang="en-US"/>
           </a:p>
@@ -864,7 +865,7 @@
           <a:p>
             <a:fld id="{18514EC9-E150-4B7A-9B8E-2980A974DF62}" type="datetimeFigureOut">
               <a:rPr lang="en-US" smtClean="0"/>
-              <a:t>10/23/2023</a:t>
+              <a:t>10/30/2023</a:t>
             </a:fld>
             <a:endParaRPr lang="en-US"/>
           </a:p>
@@ -1139,7 +1140,7 @@
           <a:p>
             <a:fld id="{18514EC9-E150-4B7A-9B8E-2980A974DF62}" type="datetimeFigureOut">
               <a:rPr lang="en-US" smtClean="0"/>
-              <a:t>10/23/2023</a:t>
+              <a:t>10/30/2023</a:t>
             </a:fld>
             <a:endParaRPr lang="en-US"/>
           </a:p>
@@ -1404,7 +1405,7 @@
           <a:p>
             <a:fld id="{18514EC9-E150-4B7A-9B8E-2980A974DF62}" type="datetimeFigureOut">
               <a:rPr lang="en-US" smtClean="0"/>
-              <a:t>10/23/2023</a:t>
+              <a:t>10/30/2023</a:t>
             </a:fld>
             <a:endParaRPr lang="en-US"/>
           </a:p>
@@ -1816,7 +1817,7 @@
           <a:p>
             <a:fld id="{18514EC9-E150-4B7A-9B8E-2980A974DF62}" type="datetimeFigureOut">
               <a:rPr lang="en-US" smtClean="0"/>
-              <a:t>10/23/2023</a:t>
+              <a:t>10/30/2023</a:t>
             </a:fld>
             <a:endParaRPr lang="en-US"/>
           </a:p>
@@ -1957,7 +1958,7 @@
           <a:p>
             <a:fld id="{18514EC9-E150-4B7A-9B8E-2980A974DF62}" type="datetimeFigureOut">
               <a:rPr lang="en-US" smtClean="0"/>
-              <a:t>10/23/2023</a:t>
+              <a:t>10/30/2023</a:t>
             </a:fld>
             <a:endParaRPr lang="en-US"/>
           </a:p>
@@ -2070,7 +2071,7 @@
           <a:p>
             <a:fld id="{18514EC9-E150-4B7A-9B8E-2980A974DF62}" type="datetimeFigureOut">
               <a:rPr lang="en-US" smtClean="0"/>
-              <a:t>10/23/2023</a:t>
+              <a:t>10/30/2023</a:t>
             </a:fld>
             <a:endParaRPr lang="en-US"/>
           </a:p>
@@ -2381,7 +2382,7 @@
           <a:p>
             <a:fld id="{18514EC9-E150-4B7A-9B8E-2980A974DF62}" type="datetimeFigureOut">
               <a:rPr lang="en-US" smtClean="0"/>
-              <a:t>10/23/2023</a:t>
+              <a:t>10/30/2023</a:t>
             </a:fld>
             <a:endParaRPr lang="en-US"/>
           </a:p>
@@ -2669,7 +2670,7 @@
           <a:p>
             <a:fld id="{18514EC9-E150-4B7A-9B8E-2980A974DF62}" type="datetimeFigureOut">
               <a:rPr lang="en-US" smtClean="0"/>
-              <a:t>10/23/2023</a:t>
+              <a:t>10/30/2023</a:t>
             </a:fld>
             <a:endParaRPr lang="en-US"/>
           </a:p>
@@ -2910,7 +2911,7 @@
           <a:p>
             <a:fld id="{18514EC9-E150-4B7A-9B8E-2980A974DF62}" type="datetimeFigureOut">
               <a:rPr lang="en-US" smtClean="0"/>
-              <a:t>10/23/2023</a:t>
+              <a:t>10/30/2023</a:t>
             </a:fld>
             <a:endParaRPr lang="en-US"/>
           </a:p>
@@ -4021,6 +4022,409 @@
 </p:sld>
 </file>
 
+<file path=ppt/slides/slide3.xml><?xml version="1.0" encoding="utf-8"?>
+<p:sld xmlns:a="http://schemas.openxmlformats.org/drawingml/2006/main" xmlns:r="http://schemas.openxmlformats.org/officeDocument/2006/relationships" xmlns:p="http://schemas.openxmlformats.org/presentationml/2006/main">
+  <p:cSld>
+    <p:spTree>
+      <p:nvGrpSpPr>
+        <p:cNvPr id="1" name=""/>
+        <p:cNvGrpSpPr/>
+        <p:nvPr/>
+      </p:nvGrpSpPr>
+      <p:grpSpPr>
+        <a:xfrm>
+          <a:off x="0" y="0"/>
+          <a:ext cx="0" cy="0"/>
+          <a:chOff x="0" y="0"/>
+          <a:chExt cx="0" cy="0"/>
+        </a:xfrm>
+      </p:grpSpPr>
+      <p:sp>
+        <p:nvSpPr>
+          <p:cNvPr id="2" name="Title 1">
+            <a:extLst>
+              <a:ext uri="{FF2B5EF4-FFF2-40B4-BE49-F238E27FC236}">
+                <a16:creationId xmlns:a16="http://schemas.microsoft.com/office/drawing/2014/main" id="{0FF1B0A5-F572-705C-0AB4-AF00DD2C6AAD}"/>
+              </a:ext>
+            </a:extLst>
+          </p:cNvPr>
+          <p:cNvSpPr>
+            <a:spLocks noGrp="1"/>
+          </p:cNvSpPr>
+          <p:nvPr>
+            <p:ph type="title"/>
+          </p:nvPr>
+        </p:nvSpPr>
+        <p:spPr/>
+        <p:txBody>
+          <a:bodyPr/>
+          <a:lstStyle/>
+          <a:p>
+            <a:pPr algn="ctr"/>
+            <a:r>
+              <a:rPr lang="en-US" dirty="0"/>
+              <a:t>EVIMO For Image Classification, 10/31</a:t>
+            </a:r>
+          </a:p>
+        </p:txBody>
+      </p:sp>
+      <p:sp>
+        <p:nvSpPr>
+          <p:cNvPr id="3" name="Content Placeholder 2">
+            <a:extLst>
+              <a:ext uri="{FF2B5EF4-FFF2-40B4-BE49-F238E27FC236}">
+                <a16:creationId xmlns:a16="http://schemas.microsoft.com/office/drawing/2014/main" id="{7373C4D2-2FB5-91E0-A248-6BE8896049A2}"/>
+              </a:ext>
+            </a:extLst>
+          </p:cNvPr>
+          <p:cNvSpPr>
+            <a:spLocks noGrp="1"/>
+          </p:cNvSpPr>
+          <p:nvPr>
+            <p:ph idx="1"/>
+          </p:nvPr>
+        </p:nvSpPr>
+        <p:spPr>
+          <a:xfrm>
+            <a:off x="838200" y="1825625"/>
+            <a:ext cx="5881719" cy="4351338"/>
+          </a:xfrm>
+        </p:spPr>
+        <p:txBody>
+          <a:bodyPr>
+            <a:normAutofit fontScale="85000" lnSpcReduction="10000"/>
+          </a:bodyPr>
+          <a:lstStyle/>
+          <a:p>
+            <a:r>
+              <a:rPr lang="en-US" dirty="0"/>
+              <a:t>EVIMO Image Classification works &amp; trains</a:t>
+            </a:r>
+          </a:p>
+          <a:p>
+            <a:pPr lvl="1"/>
+            <a:r>
+              <a:rPr lang="en-US" dirty="0"/>
+              <a:t>Accuracy ~90% after 1 epoch for 2 label classification</a:t>
+            </a:r>
+          </a:p>
+          <a:p>
+            <a:pPr lvl="1"/>
+            <a:endParaRPr lang="en-US" dirty="0"/>
+          </a:p>
+          <a:p>
+            <a:r>
+              <a:rPr lang="en-US" dirty="0"/>
+              <a:t>Using NMNIST Data:</a:t>
+            </a:r>
+          </a:p>
+          <a:p>
+            <a:pPr lvl="1"/>
+            <a:r>
+              <a:rPr lang="en-US" dirty="0"/>
+              <a:t>Found I was using too few bins per frame for EVIMO data</a:t>
+            </a:r>
+          </a:p>
+          <a:p>
+            <a:pPr lvl="2"/>
+            <a:r>
+              <a:rPr lang="en-US" dirty="0"/>
+              <a:t>Was using 4, found 16 worked well, 100 was too many</a:t>
+            </a:r>
+          </a:p>
+          <a:p>
+            <a:pPr lvl="1"/>
+            <a:endParaRPr lang="en-US" dirty="0"/>
+          </a:p>
+          <a:p>
+            <a:r>
+              <a:rPr lang="en-US" dirty="0"/>
+              <a:t>Updated EVIMO data storage process</a:t>
+            </a:r>
+          </a:p>
+          <a:p>
+            <a:pPr lvl="1"/>
+            <a:r>
+              <a:rPr lang="en-US" dirty="0"/>
+              <a:t>Significantly sped up data load time, allowing faster training</a:t>
+            </a:r>
+          </a:p>
+          <a:p>
+            <a:pPr lvl="1"/>
+            <a:r>
+              <a:rPr lang="en-US" dirty="0"/>
+              <a:t>~12 min epoch</a:t>
+            </a:r>
+          </a:p>
+          <a:p>
+            <a:pPr lvl="1"/>
+            <a:endParaRPr lang="en-US" dirty="0"/>
+          </a:p>
+        </p:txBody>
+      </p:sp>
+      <p:pic>
+        <p:nvPicPr>
+          <p:cNvPr id="5" name="Picture 4">
+            <a:extLst>
+              <a:ext uri="{FF2B5EF4-FFF2-40B4-BE49-F238E27FC236}">
+                <a16:creationId xmlns:a16="http://schemas.microsoft.com/office/drawing/2014/main" id="{A4711C45-08E8-8B2D-75AB-A907D9B70475}"/>
+              </a:ext>
+            </a:extLst>
+          </p:cNvPr>
+          <p:cNvPicPr>
+            <a:picLocks noChangeAspect="1"/>
+          </p:cNvPicPr>
+          <p:nvPr/>
+        </p:nvPicPr>
+        <p:blipFill>
+          <a:blip r:embed="rId2"/>
+          <a:stretch>
+            <a:fillRect/>
+          </a:stretch>
+        </p:blipFill>
+        <p:spPr>
+          <a:xfrm>
+            <a:off x="8554278" y="1963530"/>
+            <a:ext cx="2614117" cy="471534"/>
+          </a:xfrm>
+          <a:prstGeom prst="rect">
+            <a:avLst/>
+          </a:prstGeom>
+        </p:spPr>
+      </p:pic>
+      <p:pic>
+        <p:nvPicPr>
+          <p:cNvPr id="7" name="Picture 6">
+            <a:extLst>
+              <a:ext uri="{FF2B5EF4-FFF2-40B4-BE49-F238E27FC236}">
+                <a16:creationId xmlns:a16="http://schemas.microsoft.com/office/drawing/2014/main" id="{55FC61F1-9E14-A61D-59C1-80E72529E3F0}"/>
+              </a:ext>
+            </a:extLst>
+          </p:cNvPr>
+          <p:cNvPicPr>
+            <a:picLocks noChangeAspect="1"/>
+          </p:cNvPicPr>
+          <p:nvPr/>
+        </p:nvPicPr>
+        <p:blipFill>
+          <a:blip r:embed="rId3"/>
+          <a:stretch>
+            <a:fillRect/>
+          </a:stretch>
+        </p:blipFill>
+        <p:spPr>
+          <a:xfrm>
+            <a:off x="8737585" y="4819522"/>
+            <a:ext cx="2191056" cy="200053"/>
+          </a:xfrm>
+          <a:prstGeom prst="rect">
+            <a:avLst/>
+          </a:prstGeom>
+        </p:spPr>
+      </p:pic>
+      <p:sp>
+        <p:nvSpPr>
+          <p:cNvPr id="8" name="TextBox 7">
+            <a:extLst>
+              <a:ext uri="{FF2B5EF4-FFF2-40B4-BE49-F238E27FC236}">
+                <a16:creationId xmlns:a16="http://schemas.microsoft.com/office/drawing/2014/main" id="{A0A8AD45-A3B0-FDC5-F6D6-E584D0C1132A}"/>
+              </a:ext>
+            </a:extLst>
+          </p:cNvPr>
+          <p:cNvSpPr txBox="1"/>
+          <p:nvPr/>
+        </p:nvSpPr>
+        <p:spPr>
+          <a:xfrm>
+            <a:off x="7347108" y="4734882"/>
+            <a:ext cx="1221423" cy="369332"/>
+          </a:xfrm>
+          <a:prstGeom prst="rect">
+            <a:avLst/>
+          </a:prstGeom>
+          <a:noFill/>
+        </p:spPr>
+        <p:txBody>
+          <a:bodyPr wrap="square" rtlCol="0">
+            <a:spAutoFit/>
+          </a:bodyPr>
+          <a:lstStyle/>
+          <a:p>
+            <a:r>
+              <a:rPr lang="en-US" dirty="0"/>
+              <a:t>Previously:</a:t>
+            </a:r>
+          </a:p>
+        </p:txBody>
+      </p:sp>
+      <p:pic>
+        <p:nvPicPr>
+          <p:cNvPr id="10" name="Picture 9">
+            <a:extLst>
+              <a:ext uri="{FF2B5EF4-FFF2-40B4-BE49-F238E27FC236}">
+                <a16:creationId xmlns:a16="http://schemas.microsoft.com/office/drawing/2014/main" id="{D371E334-53D9-6AE0-6F86-62825B68B88C}"/>
+              </a:ext>
+            </a:extLst>
+          </p:cNvPr>
+          <p:cNvPicPr>
+            <a:picLocks noChangeAspect="1"/>
+          </p:cNvPicPr>
+          <p:nvPr/>
+        </p:nvPicPr>
+        <p:blipFill>
+          <a:blip r:embed="rId4"/>
+          <a:stretch>
+            <a:fillRect/>
+          </a:stretch>
+        </p:blipFill>
+        <p:spPr>
+          <a:xfrm>
+            <a:off x="8737585" y="5007359"/>
+            <a:ext cx="3162804" cy="212269"/>
+          </a:xfrm>
+          <a:prstGeom prst="rect">
+            <a:avLst/>
+          </a:prstGeom>
+        </p:spPr>
+      </p:pic>
+      <p:sp>
+        <p:nvSpPr>
+          <p:cNvPr id="13" name="TextBox 12">
+            <a:extLst>
+              <a:ext uri="{FF2B5EF4-FFF2-40B4-BE49-F238E27FC236}">
+                <a16:creationId xmlns:a16="http://schemas.microsoft.com/office/drawing/2014/main" id="{E40CA6B3-828F-4088-9162-6907D960E53D}"/>
+              </a:ext>
+            </a:extLst>
+          </p:cNvPr>
+          <p:cNvSpPr txBox="1"/>
+          <p:nvPr/>
+        </p:nvSpPr>
+        <p:spPr>
+          <a:xfrm>
+            <a:off x="7814159" y="5326138"/>
+            <a:ext cx="740119" cy="369332"/>
+          </a:xfrm>
+          <a:prstGeom prst="rect">
+            <a:avLst/>
+          </a:prstGeom>
+          <a:noFill/>
+        </p:spPr>
+        <p:txBody>
+          <a:bodyPr wrap="square" rtlCol="0">
+            <a:spAutoFit/>
+          </a:bodyPr>
+          <a:lstStyle/>
+          <a:p>
+            <a:r>
+              <a:rPr lang="en-US" dirty="0"/>
+              <a:t>Now:</a:t>
+            </a:r>
+          </a:p>
+        </p:txBody>
+      </p:sp>
+      <p:pic>
+        <p:nvPicPr>
+          <p:cNvPr id="15" name="Picture 14">
+            <a:extLst>
+              <a:ext uri="{FF2B5EF4-FFF2-40B4-BE49-F238E27FC236}">
+                <a16:creationId xmlns:a16="http://schemas.microsoft.com/office/drawing/2014/main" id="{40600524-64F9-138A-F98B-3B7EBD5E3033}"/>
+              </a:ext>
+            </a:extLst>
+          </p:cNvPr>
+          <p:cNvPicPr>
+            <a:picLocks noChangeAspect="1"/>
+          </p:cNvPicPr>
+          <p:nvPr/>
+        </p:nvPicPr>
+        <p:blipFill>
+          <a:blip r:embed="rId5"/>
+          <a:stretch>
+            <a:fillRect/>
+          </a:stretch>
+        </p:blipFill>
+        <p:spPr>
+          <a:xfrm>
+            <a:off x="8737585" y="5410778"/>
+            <a:ext cx="1752845" cy="200053"/>
+          </a:xfrm>
+          <a:prstGeom prst="rect">
+            <a:avLst/>
+          </a:prstGeom>
+        </p:spPr>
+      </p:pic>
+      <p:pic>
+        <p:nvPicPr>
+          <p:cNvPr id="17" name="Picture 16">
+            <a:extLst>
+              <a:ext uri="{FF2B5EF4-FFF2-40B4-BE49-F238E27FC236}">
+                <a16:creationId xmlns:a16="http://schemas.microsoft.com/office/drawing/2014/main" id="{4CA855F2-4FB4-6F7F-CF88-6C64ADA4E506}"/>
+              </a:ext>
+            </a:extLst>
+          </p:cNvPr>
+          <p:cNvPicPr>
+            <a:picLocks noChangeAspect="1"/>
+          </p:cNvPicPr>
+          <p:nvPr/>
+        </p:nvPicPr>
+        <p:blipFill>
+          <a:blip r:embed="rId6"/>
+          <a:stretch>
+            <a:fillRect/>
+          </a:stretch>
+        </p:blipFill>
+        <p:spPr>
+          <a:xfrm>
+            <a:off x="8724333" y="5628942"/>
+            <a:ext cx="3010320" cy="173544"/>
+          </a:xfrm>
+          <a:prstGeom prst="rect">
+            <a:avLst/>
+          </a:prstGeom>
+        </p:spPr>
+      </p:pic>
+      <p:pic>
+        <p:nvPicPr>
+          <p:cNvPr id="19" name="Picture 18">
+            <a:extLst>
+              <a:ext uri="{FF2B5EF4-FFF2-40B4-BE49-F238E27FC236}">
+                <a16:creationId xmlns:a16="http://schemas.microsoft.com/office/drawing/2014/main" id="{340302C1-402C-9759-59F1-98C48E1F7256}"/>
+              </a:ext>
+            </a:extLst>
+          </p:cNvPr>
+          <p:cNvPicPr>
+            <a:picLocks noChangeAspect="1"/>
+          </p:cNvPicPr>
+          <p:nvPr/>
+        </p:nvPicPr>
+        <p:blipFill>
+          <a:blip r:embed="rId7"/>
+          <a:stretch>
+            <a:fillRect/>
+          </a:stretch>
+        </p:blipFill>
+        <p:spPr>
+          <a:xfrm>
+            <a:off x="8568531" y="2861433"/>
+            <a:ext cx="2614117" cy="423238"/>
+          </a:xfrm>
+          <a:prstGeom prst="rect">
+            <a:avLst/>
+          </a:prstGeom>
+        </p:spPr>
+      </p:pic>
+    </p:spTree>
+    <p:extLst>
+      <p:ext uri="{BB962C8B-B14F-4D97-AF65-F5344CB8AC3E}">
+        <p14:creationId xmlns:p14="http://schemas.microsoft.com/office/powerpoint/2010/main" val="463751845"/>
+      </p:ext>
+    </p:extLst>
+  </p:cSld>
+  <p:clrMapOvr>
+    <a:masterClrMapping/>
+  </p:clrMapOvr>
+</p:sld>
+</file>
+
 <file path=ppt/theme/theme1.xml><?xml version="1.0" encoding="utf-8"?>
 <a:theme xmlns:a="http://schemas.openxmlformats.org/drawingml/2006/main" name="Office Theme">
   <a:themeElements>

</xml_diff>

<commit_message>
Week 1 of trying an SNN for obj det, with EVIMO
</commit_message>
<xml_diff>
--- a/SNN.pptx
+++ b/SNN.pptx
@@ -8,6 +8,7 @@
     <p:sldId id="257" r:id="rId2"/>
     <p:sldId id="259" r:id="rId3"/>
     <p:sldId id="260" r:id="rId4"/>
+    <p:sldId id="261" r:id="rId5"/>
   </p:sldIdLst>
   <p:sldSz cx="12192000" cy="6858000"/>
   <p:notesSz cx="6858000" cy="9144000"/>
@@ -261,7 +262,7 @@
           <a:p>
             <a:fld id="{18514EC9-E150-4B7A-9B8E-2980A974DF62}" type="datetimeFigureOut">
               <a:rPr lang="en-US" smtClean="0"/>
-              <a:t>10/30/2023</a:t>
+              <a:t>11/6/2023</a:t>
             </a:fld>
             <a:endParaRPr lang="en-US"/>
           </a:p>
@@ -459,7 +460,7 @@
           <a:p>
             <a:fld id="{18514EC9-E150-4B7A-9B8E-2980A974DF62}" type="datetimeFigureOut">
               <a:rPr lang="en-US" smtClean="0"/>
-              <a:t>10/30/2023</a:t>
+              <a:t>11/6/2023</a:t>
             </a:fld>
             <a:endParaRPr lang="en-US"/>
           </a:p>
@@ -667,7 +668,7 @@
           <a:p>
             <a:fld id="{18514EC9-E150-4B7A-9B8E-2980A974DF62}" type="datetimeFigureOut">
               <a:rPr lang="en-US" smtClean="0"/>
-              <a:t>10/30/2023</a:t>
+              <a:t>11/6/2023</a:t>
             </a:fld>
             <a:endParaRPr lang="en-US"/>
           </a:p>
@@ -865,7 +866,7 @@
           <a:p>
             <a:fld id="{18514EC9-E150-4B7A-9B8E-2980A974DF62}" type="datetimeFigureOut">
               <a:rPr lang="en-US" smtClean="0"/>
-              <a:t>10/30/2023</a:t>
+              <a:t>11/6/2023</a:t>
             </a:fld>
             <a:endParaRPr lang="en-US"/>
           </a:p>
@@ -1140,7 +1141,7 @@
           <a:p>
             <a:fld id="{18514EC9-E150-4B7A-9B8E-2980A974DF62}" type="datetimeFigureOut">
               <a:rPr lang="en-US" smtClean="0"/>
-              <a:t>10/30/2023</a:t>
+              <a:t>11/6/2023</a:t>
             </a:fld>
             <a:endParaRPr lang="en-US"/>
           </a:p>
@@ -1405,7 +1406,7 @@
           <a:p>
             <a:fld id="{18514EC9-E150-4B7A-9B8E-2980A974DF62}" type="datetimeFigureOut">
               <a:rPr lang="en-US" smtClean="0"/>
-              <a:t>10/30/2023</a:t>
+              <a:t>11/6/2023</a:t>
             </a:fld>
             <a:endParaRPr lang="en-US"/>
           </a:p>
@@ -1817,7 +1818,7 @@
           <a:p>
             <a:fld id="{18514EC9-E150-4B7A-9B8E-2980A974DF62}" type="datetimeFigureOut">
               <a:rPr lang="en-US" smtClean="0"/>
-              <a:t>10/30/2023</a:t>
+              <a:t>11/6/2023</a:t>
             </a:fld>
             <a:endParaRPr lang="en-US"/>
           </a:p>
@@ -1958,7 +1959,7 @@
           <a:p>
             <a:fld id="{18514EC9-E150-4B7A-9B8E-2980A974DF62}" type="datetimeFigureOut">
               <a:rPr lang="en-US" smtClean="0"/>
-              <a:t>10/30/2023</a:t>
+              <a:t>11/6/2023</a:t>
             </a:fld>
             <a:endParaRPr lang="en-US"/>
           </a:p>
@@ -2071,7 +2072,7 @@
           <a:p>
             <a:fld id="{18514EC9-E150-4B7A-9B8E-2980A974DF62}" type="datetimeFigureOut">
               <a:rPr lang="en-US" smtClean="0"/>
-              <a:t>10/30/2023</a:t>
+              <a:t>11/6/2023</a:t>
             </a:fld>
             <a:endParaRPr lang="en-US"/>
           </a:p>
@@ -2382,7 +2383,7 @@
           <a:p>
             <a:fld id="{18514EC9-E150-4B7A-9B8E-2980A974DF62}" type="datetimeFigureOut">
               <a:rPr lang="en-US" smtClean="0"/>
-              <a:t>10/30/2023</a:t>
+              <a:t>11/6/2023</a:t>
             </a:fld>
             <a:endParaRPr lang="en-US"/>
           </a:p>
@@ -2670,7 +2671,7 @@
           <a:p>
             <a:fld id="{18514EC9-E150-4B7A-9B8E-2980A974DF62}" type="datetimeFigureOut">
               <a:rPr lang="en-US" smtClean="0"/>
-              <a:t>10/30/2023</a:t>
+              <a:t>11/6/2023</a:t>
             </a:fld>
             <a:endParaRPr lang="en-US"/>
           </a:p>
@@ -2911,7 +2912,7 @@
           <a:p>
             <a:fld id="{18514EC9-E150-4B7A-9B8E-2980A974DF62}" type="datetimeFigureOut">
               <a:rPr lang="en-US" smtClean="0"/>
-              <a:t>10/30/2023</a:t>
+              <a:t>11/6/2023</a:t>
             </a:fld>
             <a:endParaRPr lang="en-US"/>
           </a:p>
@@ -4425,6 +4426,217 @@
 </p:sld>
 </file>
 
+<file path=ppt/slides/slide4.xml><?xml version="1.0" encoding="utf-8"?>
+<p:sld xmlns:a="http://schemas.openxmlformats.org/drawingml/2006/main" xmlns:r="http://schemas.openxmlformats.org/officeDocument/2006/relationships" xmlns:p="http://schemas.openxmlformats.org/presentationml/2006/main">
+  <p:cSld>
+    <p:spTree>
+      <p:nvGrpSpPr>
+        <p:cNvPr id="1" name=""/>
+        <p:cNvGrpSpPr/>
+        <p:nvPr/>
+      </p:nvGrpSpPr>
+      <p:grpSpPr>
+        <a:xfrm>
+          <a:off x="0" y="0"/>
+          <a:ext cx="0" cy="0"/>
+          <a:chOff x="0" y="0"/>
+          <a:chExt cx="0" cy="0"/>
+        </a:xfrm>
+      </p:grpSpPr>
+      <p:sp>
+        <p:nvSpPr>
+          <p:cNvPr id="2" name="Title 1">
+            <a:extLst>
+              <a:ext uri="{FF2B5EF4-FFF2-40B4-BE49-F238E27FC236}">
+                <a16:creationId xmlns:a16="http://schemas.microsoft.com/office/drawing/2014/main" id="{B302469E-551D-2BE4-C7B0-B6CC0F504E75}"/>
+              </a:ext>
+            </a:extLst>
+          </p:cNvPr>
+          <p:cNvSpPr>
+            <a:spLocks noGrp="1"/>
+          </p:cNvSpPr>
+          <p:nvPr>
+            <p:ph type="title"/>
+          </p:nvPr>
+        </p:nvSpPr>
+        <p:spPr/>
+        <p:txBody>
+          <a:bodyPr/>
+          <a:lstStyle/>
+          <a:p>
+            <a:pPr algn="ctr"/>
+            <a:r>
+              <a:rPr lang="en-US" dirty="0"/>
+              <a:t>EVIMO for Object Detection 11/7</a:t>
+            </a:r>
+          </a:p>
+        </p:txBody>
+      </p:sp>
+      <p:sp>
+        <p:nvSpPr>
+          <p:cNvPr id="3" name="Content Placeholder 2">
+            <a:extLst>
+              <a:ext uri="{FF2B5EF4-FFF2-40B4-BE49-F238E27FC236}">
+                <a16:creationId xmlns:a16="http://schemas.microsoft.com/office/drawing/2014/main" id="{0FB6E537-4E7C-2045-BDE4-60B8D8E6A097}"/>
+              </a:ext>
+            </a:extLst>
+          </p:cNvPr>
+          <p:cNvSpPr>
+            <a:spLocks noGrp="1"/>
+          </p:cNvSpPr>
+          <p:nvPr>
+            <p:ph idx="1"/>
+          </p:nvPr>
+        </p:nvSpPr>
+        <p:spPr>
+          <a:xfrm>
+            <a:off x="838200" y="1825624"/>
+            <a:ext cx="5053236" cy="4734735"/>
+          </a:xfrm>
+        </p:spPr>
+        <p:txBody>
+          <a:bodyPr>
+            <a:normAutofit lnSpcReduction="10000"/>
+          </a:bodyPr>
+          <a:lstStyle/>
+          <a:p>
+            <a:r>
+              <a:rPr lang="en-US" sz="2000" dirty="0"/>
+              <a:t>Should be able to get both bounding boxes and class from one model</a:t>
+            </a:r>
+          </a:p>
+          <a:p>
+            <a:pPr lvl="1"/>
+            <a:r>
+              <a:rPr lang="en-US" sz="1600" dirty="0"/>
+              <a:t>Single Shot </a:t>
+            </a:r>
+            <a:r>
+              <a:rPr lang="en-US" sz="1600" dirty="0" err="1"/>
+              <a:t>MultiBox</a:t>
+            </a:r>
+            <a:r>
+              <a:rPr lang="en-US" sz="1600" dirty="0"/>
+              <a:t> Detectors able to model object detection as regression/classification program</a:t>
+            </a:r>
+          </a:p>
+          <a:p>
+            <a:pPr lvl="1"/>
+            <a:endParaRPr lang="en-US" sz="2000" dirty="0"/>
+          </a:p>
+          <a:p>
+            <a:r>
+              <a:rPr lang="en-US" sz="2000" dirty="0"/>
+              <a:t>Preliminary tests of using bounding box as target:</a:t>
+            </a:r>
+          </a:p>
+          <a:p>
+            <a:pPr lvl="1"/>
+            <a:r>
+              <a:rPr lang="en-US" sz="1600" dirty="0"/>
+              <a:t>Model unable to adjust quickly enough for the large values of x, y</a:t>
+            </a:r>
+          </a:p>
+          <a:p>
+            <a:pPr lvl="2"/>
+            <a:r>
+              <a:rPr lang="en-US" sz="1600" dirty="0"/>
+              <a:t>During training, saw variations of up to 5 in readouts, when target bounding boxes have x, y of 300</a:t>
+            </a:r>
+          </a:p>
+          <a:p>
+            <a:pPr lvl="2"/>
+            <a:r>
+              <a:rPr lang="en-US" sz="1600" dirty="0"/>
+              <a:t>Tried with several learning rates</a:t>
+            </a:r>
+          </a:p>
+          <a:p>
+            <a:pPr lvl="2"/>
+            <a:r>
+              <a:rPr lang="en-US" sz="1600" dirty="0"/>
+              <a:t>May try adding </a:t>
+            </a:r>
+            <a:r>
+              <a:rPr lang="en-US" sz="1600" dirty="0" err="1"/>
+              <a:t>Softmax</a:t>
+            </a:r>
+            <a:r>
+              <a:rPr lang="en-US" sz="1600" dirty="0"/>
+              <a:t> loss</a:t>
+            </a:r>
+          </a:p>
+          <a:p>
+            <a:pPr marL="914400" lvl="2" indent="0">
+              <a:buNone/>
+            </a:pPr>
+            <a:endParaRPr lang="en-US" sz="1600" dirty="0"/>
+          </a:p>
+          <a:p>
+            <a:r>
+              <a:rPr lang="en-US" sz="2000" dirty="0"/>
+              <a:t>Updated model accuracy / error to be based on </a:t>
+            </a:r>
+            <a:r>
+              <a:rPr lang="en-US" sz="2000" dirty="0" err="1"/>
+              <a:t>IoU</a:t>
+            </a:r>
+            <a:endParaRPr lang="en-US" sz="2000" dirty="0"/>
+          </a:p>
+          <a:p>
+            <a:endParaRPr lang="en-US" dirty="0"/>
+          </a:p>
+          <a:p>
+            <a:endParaRPr lang="en-US" dirty="0"/>
+          </a:p>
+          <a:p>
+            <a:endParaRPr lang="en-US" dirty="0"/>
+          </a:p>
+        </p:txBody>
+      </p:sp>
+      <p:pic>
+        <p:nvPicPr>
+          <p:cNvPr id="5" name="Picture 4">
+            <a:extLst>
+              <a:ext uri="{FF2B5EF4-FFF2-40B4-BE49-F238E27FC236}">
+                <a16:creationId xmlns:a16="http://schemas.microsoft.com/office/drawing/2014/main" id="{FCBB0942-ECFE-6679-3D23-2D1FA57CA552}"/>
+              </a:ext>
+            </a:extLst>
+          </p:cNvPr>
+          <p:cNvPicPr>
+            <a:picLocks noChangeAspect="1"/>
+          </p:cNvPicPr>
+          <p:nvPr/>
+        </p:nvPicPr>
+        <p:blipFill>
+          <a:blip r:embed="rId2"/>
+          <a:stretch>
+            <a:fillRect/>
+          </a:stretch>
+        </p:blipFill>
+        <p:spPr>
+          <a:xfrm>
+            <a:off x="7086004" y="2811673"/>
+            <a:ext cx="4267796" cy="2762636"/>
+          </a:xfrm>
+          <a:prstGeom prst="rect">
+            <a:avLst/>
+          </a:prstGeom>
+        </p:spPr>
+      </p:pic>
+    </p:spTree>
+    <p:extLst>
+      <p:ext uri="{BB962C8B-B14F-4D97-AF65-F5344CB8AC3E}">
+        <p14:creationId xmlns:p14="http://schemas.microsoft.com/office/powerpoint/2010/main" val="1610270372"/>
+      </p:ext>
+    </p:extLst>
+  </p:cSld>
+  <p:clrMapOvr>
+    <a:masterClrMapping/>
+  </p:clrMapOvr>
+</p:sld>
+</file>
+
 <file path=ppt/theme/theme1.xml><?xml version="1.0" encoding="utf-8"?>
 <a:theme xmlns:a="http://schemas.openxmlformats.org/drawingml/2006/main" name="Office Theme">
   <a:themeElements>

</xml_diff>

<commit_message>
Adding SSDHeads, initial work on merging backbone & heads
</commit_message>
<xml_diff>
--- a/SNN.pptx
+++ b/SNN.pptx
@@ -9,6 +9,7 @@
     <p:sldId id="259" r:id="rId3"/>
     <p:sldId id="260" r:id="rId4"/>
     <p:sldId id="261" r:id="rId5"/>
+    <p:sldId id="262" r:id="rId6"/>
   </p:sldIdLst>
   <p:sldSz cx="12192000" cy="6858000"/>
   <p:notesSz cx="6858000" cy="9144000"/>
@@ -262,7 +263,7 @@
           <a:p>
             <a:fld id="{18514EC9-E150-4B7A-9B8E-2980A974DF62}" type="datetimeFigureOut">
               <a:rPr lang="en-US" smtClean="0"/>
-              <a:t>11/6/2023</a:t>
+              <a:t>11/13/2023</a:t>
             </a:fld>
             <a:endParaRPr lang="en-US"/>
           </a:p>
@@ -460,7 +461,7 @@
           <a:p>
             <a:fld id="{18514EC9-E150-4B7A-9B8E-2980A974DF62}" type="datetimeFigureOut">
               <a:rPr lang="en-US" smtClean="0"/>
-              <a:t>11/6/2023</a:t>
+              <a:t>11/13/2023</a:t>
             </a:fld>
             <a:endParaRPr lang="en-US"/>
           </a:p>
@@ -668,7 +669,7 @@
           <a:p>
             <a:fld id="{18514EC9-E150-4B7A-9B8E-2980A974DF62}" type="datetimeFigureOut">
               <a:rPr lang="en-US" smtClean="0"/>
-              <a:t>11/6/2023</a:t>
+              <a:t>11/13/2023</a:t>
             </a:fld>
             <a:endParaRPr lang="en-US"/>
           </a:p>
@@ -866,7 +867,7 @@
           <a:p>
             <a:fld id="{18514EC9-E150-4B7A-9B8E-2980A974DF62}" type="datetimeFigureOut">
               <a:rPr lang="en-US" smtClean="0"/>
-              <a:t>11/6/2023</a:t>
+              <a:t>11/13/2023</a:t>
             </a:fld>
             <a:endParaRPr lang="en-US"/>
           </a:p>
@@ -1141,7 +1142,7 @@
           <a:p>
             <a:fld id="{18514EC9-E150-4B7A-9B8E-2980A974DF62}" type="datetimeFigureOut">
               <a:rPr lang="en-US" smtClean="0"/>
-              <a:t>11/6/2023</a:t>
+              <a:t>11/13/2023</a:t>
             </a:fld>
             <a:endParaRPr lang="en-US"/>
           </a:p>
@@ -1406,7 +1407,7 @@
           <a:p>
             <a:fld id="{18514EC9-E150-4B7A-9B8E-2980A974DF62}" type="datetimeFigureOut">
               <a:rPr lang="en-US" smtClean="0"/>
-              <a:t>11/6/2023</a:t>
+              <a:t>11/13/2023</a:t>
             </a:fld>
             <a:endParaRPr lang="en-US"/>
           </a:p>
@@ -1818,7 +1819,7 @@
           <a:p>
             <a:fld id="{18514EC9-E150-4B7A-9B8E-2980A974DF62}" type="datetimeFigureOut">
               <a:rPr lang="en-US" smtClean="0"/>
-              <a:t>11/6/2023</a:t>
+              <a:t>11/13/2023</a:t>
             </a:fld>
             <a:endParaRPr lang="en-US"/>
           </a:p>
@@ -1959,7 +1960,7 @@
           <a:p>
             <a:fld id="{18514EC9-E150-4B7A-9B8E-2980A974DF62}" type="datetimeFigureOut">
               <a:rPr lang="en-US" smtClean="0"/>
-              <a:t>11/6/2023</a:t>
+              <a:t>11/13/2023</a:t>
             </a:fld>
             <a:endParaRPr lang="en-US"/>
           </a:p>
@@ -2072,7 +2073,7 @@
           <a:p>
             <a:fld id="{18514EC9-E150-4B7A-9B8E-2980A974DF62}" type="datetimeFigureOut">
               <a:rPr lang="en-US" smtClean="0"/>
-              <a:t>11/6/2023</a:t>
+              <a:t>11/13/2023</a:t>
             </a:fld>
             <a:endParaRPr lang="en-US"/>
           </a:p>
@@ -2383,7 +2384,7 @@
           <a:p>
             <a:fld id="{18514EC9-E150-4B7A-9B8E-2980A974DF62}" type="datetimeFigureOut">
               <a:rPr lang="en-US" smtClean="0"/>
-              <a:t>11/6/2023</a:t>
+              <a:t>11/13/2023</a:t>
             </a:fld>
             <a:endParaRPr lang="en-US"/>
           </a:p>
@@ -2671,7 +2672,7 @@
           <a:p>
             <a:fld id="{18514EC9-E150-4B7A-9B8E-2980A974DF62}" type="datetimeFigureOut">
               <a:rPr lang="en-US" smtClean="0"/>
-              <a:t>11/6/2023</a:t>
+              <a:t>11/13/2023</a:t>
             </a:fld>
             <a:endParaRPr lang="en-US"/>
           </a:p>
@@ -2912,7 +2913,7 @@
           <a:p>
             <a:fld id="{18514EC9-E150-4B7A-9B8E-2980A974DF62}" type="datetimeFigureOut">
               <a:rPr lang="en-US" smtClean="0"/>
-              <a:t>11/6/2023</a:t>
+              <a:t>11/13/2023</a:t>
             </a:fld>
             <a:endParaRPr lang="en-US"/>
           </a:p>
@@ -4637,6 +4638,182 @@
 </p:sld>
 </file>
 
+<file path=ppt/slides/slide5.xml><?xml version="1.0" encoding="utf-8"?>
+<p:sld xmlns:a="http://schemas.openxmlformats.org/drawingml/2006/main" xmlns:r="http://schemas.openxmlformats.org/officeDocument/2006/relationships" xmlns:p="http://schemas.openxmlformats.org/presentationml/2006/main">
+  <p:cSld>
+    <p:spTree>
+      <p:nvGrpSpPr>
+        <p:cNvPr id="1" name=""/>
+        <p:cNvGrpSpPr/>
+        <p:nvPr/>
+      </p:nvGrpSpPr>
+      <p:grpSpPr>
+        <a:xfrm>
+          <a:off x="0" y="0"/>
+          <a:ext cx="0" cy="0"/>
+          <a:chOff x="0" y="0"/>
+          <a:chExt cx="0" cy="0"/>
+        </a:xfrm>
+      </p:grpSpPr>
+      <p:sp>
+        <p:nvSpPr>
+          <p:cNvPr id="2" name="Title 1">
+            <a:extLst>
+              <a:ext uri="{FF2B5EF4-FFF2-40B4-BE49-F238E27FC236}">
+                <a16:creationId xmlns:a16="http://schemas.microsoft.com/office/drawing/2014/main" id="{822B101D-696C-1843-6A6F-5D3B79D0C166}"/>
+              </a:ext>
+            </a:extLst>
+          </p:cNvPr>
+          <p:cNvSpPr>
+            <a:spLocks noGrp="1"/>
+          </p:cNvSpPr>
+          <p:nvPr>
+            <p:ph type="title"/>
+          </p:nvPr>
+        </p:nvSpPr>
+        <p:spPr/>
+        <p:txBody>
+          <a:bodyPr/>
+          <a:lstStyle/>
+          <a:p>
+            <a:pPr algn="ctr"/>
+            <a:r>
+              <a:rPr lang="en-US" dirty="0"/>
+              <a:t>EVIMO for Object Detection 11/13</a:t>
+            </a:r>
+          </a:p>
+        </p:txBody>
+      </p:sp>
+      <p:sp>
+        <p:nvSpPr>
+          <p:cNvPr id="3" name="Content Placeholder 2">
+            <a:extLst>
+              <a:ext uri="{FF2B5EF4-FFF2-40B4-BE49-F238E27FC236}">
+                <a16:creationId xmlns:a16="http://schemas.microsoft.com/office/drawing/2014/main" id="{4DF1580F-D6FF-48E9-EA60-46B2A4782249}"/>
+              </a:ext>
+            </a:extLst>
+          </p:cNvPr>
+          <p:cNvSpPr>
+            <a:spLocks noGrp="1"/>
+          </p:cNvSpPr>
+          <p:nvPr>
+            <p:ph idx="1"/>
+          </p:nvPr>
+        </p:nvSpPr>
+        <p:spPr>
+          <a:xfrm>
+            <a:off x="838200" y="1825625"/>
+            <a:ext cx="4537736" cy="4351338"/>
+          </a:xfrm>
+        </p:spPr>
+        <p:txBody>
+          <a:bodyPr>
+            <a:normAutofit fontScale="92500" lnSpcReduction="10000"/>
+          </a:bodyPr>
+          <a:lstStyle/>
+          <a:p>
+            <a:r>
+              <a:rPr lang="en-US" dirty="0"/>
+              <a:t>Updated event representation to Voxel Grid</a:t>
+            </a:r>
+          </a:p>
+          <a:p>
+            <a:endParaRPr lang="en-US" dirty="0"/>
+          </a:p>
+          <a:p>
+            <a:r>
+              <a:rPr lang="en-US" dirty="0"/>
+              <a:t>Created SSD Heads for object detection model</a:t>
+            </a:r>
+          </a:p>
+          <a:p>
+            <a:pPr lvl="1"/>
+            <a:r>
+              <a:rPr lang="en-US" dirty="0"/>
+              <a:t>Using same </a:t>
+            </a:r>
+            <a:r>
+              <a:rPr lang="en-US" dirty="0" err="1"/>
+              <a:t>LIFLayer</a:t>
+            </a:r>
+            <a:r>
+              <a:rPr lang="en-US" dirty="0"/>
+              <a:t> Conv2D from </a:t>
+            </a:r>
+            <a:r>
+              <a:rPr lang="en-US" dirty="0" err="1"/>
+              <a:t>Lenet-Decolle</a:t>
+            </a:r>
+            <a:r>
+              <a:rPr lang="en-US" dirty="0"/>
+              <a:t> Model</a:t>
+            </a:r>
+          </a:p>
+          <a:p>
+            <a:endParaRPr lang="en-US" dirty="0"/>
+          </a:p>
+          <a:p>
+            <a:r>
+              <a:rPr lang="en-US" dirty="0"/>
+              <a:t>Working on using current </a:t>
+            </a:r>
+            <a:r>
+              <a:rPr lang="en-US" dirty="0" err="1"/>
+              <a:t>Lenet-Decolle</a:t>
+            </a:r>
+            <a:r>
+              <a:rPr lang="en-US" dirty="0"/>
+              <a:t> model as backbone for SSD Heads</a:t>
+            </a:r>
+          </a:p>
+          <a:p>
+            <a:endParaRPr lang="en-US" dirty="0"/>
+          </a:p>
+        </p:txBody>
+      </p:sp>
+      <p:pic>
+        <p:nvPicPr>
+          <p:cNvPr id="5" name="Picture 4">
+            <a:extLst>
+              <a:ext uri="{FF2B5EF4-FFF2-40B4-BE49-F238E27FC236}">
+                <a16:creationId xmlns:a16="http://schemas.microsoft.com/office/drawing/2014/main" id="{06F0D944-FF7B-479A-570A-5F76BEB09EC2}"/>
+              </a:ext>
+            </a:extLst>
+          </p:cNvPr>
+          <p:cNvPicPr>
+            <a:picLocks noChangeAspect="1"/>
+          </p:cNvPicPr>
+          <p:nvPr/>
+        </p:nvPicPr>
+        <p:blipFill>
+          <a:blip r:embed="rId2"/>
+          <a:stretch>
+            <a:fillRect/>
+          </a:stretch>
+        </p:blipFill>
+        <p:spPr>
+          <a:xfrm>
+            <a:off x="5715378" y="3373293"/>
+            <a:ext cx="6379772" cy="1040571"/>
+          </a:xfrm>
+          <a:prstGeom prst="rect">
+            <a:avLst/>
+          </a:prstGeom>
+        </p:spPr>
+      </p:pic>
+    </p:spTree>
+    <p:extLst>
+      <p:ext uri="{BB962C8B-B14F-4D97-AF65-F5344CB8AC3E}">
+        <p14:creationId xmlns:p14="http://schemas.microsoft.com/office/powerpoint/2010/main" val="1254658762"/>
+      </p:ext>
+    </p:extLst>
+  </p:cSld>
+  <p:clrMapOvr>
+    <a:masterClrMapping/>
+  </p:clrMapOvr>
+</p:sld>
+</file>
+
 <file path=ppt/theme/theme1.xml><?xml version="1.0" encoding="utf-8"?>
 <a:theme xmlns:a="http://schemas.openxmlformats.org/drawingml/2006/main" name="Office Theme">
   <a:themeElements>

</xml_diff>

<commit_message>
Committing pptx updates from 2 weeks ago
</commit_message>
<xml_diff>
--- a/SNN.pptx
+++ b/SNN.pptx
@@ -263,7 +263,7 @@
           <a:p>
             <a:fld id="{18514EC9-E150-4B7A-9B8E-2980A974DF62}" type="datetimeFigureOut">
               <a:rPr lang="en-US" smtClean="0"/>
-              <a:t>11/13/2023</a:t>
+              <a:t>11/14/2023</a:t>
             </a:fld>
             <a:endParaRPr lang="en-US"/>
           </a:p>
@@ -461,7 +461,7 @@
           <a:p>
             <a:fld id="{18514EC9-E150-4B7A-9B8E-2980A974DF62}" type="datetimeFigureOut">
               <a:rPr lang="en-US" smtClean="0"/>
-              <a:t>11/13/2023</a:t>
+              <a:t>11/14/2023</a:t>
             </a:fld>
             <a:endParaRPr lang="en-US"/>
           </a:p>
@@ -669,7 +669,7 @@
           <a:p>
             <a:fld id="{18514EC9-E150-4B7A-9B8E-2980A974DF62}" type="datetimeFigureOut">
               <a:rPr lang="en-US" smtClean="0"/>
-              <a:t>11/13/2023</a:t>
+              <a:t>11/14/2023</a:t>
             </a:fld>
             <a:endParaRPr lang="en-US"/>
           </a:p>
@@ -867,7 +867,7 @@
           <a:p>
             <a:fld id="{18514EC9-E150-4B7A-9B8E-2980A974DF62}" type="datetimeFigureOut">
               <a:rPr lang="en-US" smtClean="0"/>
-              <a:t>11/13/2023</a:t>
+              <a:t>11/14/2023</a:t>
             </a:fld>
             <a:endParaRPr lang="en-US"/>
           </a:p>
@@ -1142,7 +1142,7 @@
           <a:p>
             <a:fld id="{18514EC9-E150-4B7A-9B8E-2980A974DF62}" type="datetimeFigureOut">
               <a:rPr lang="en-US" smtClean="0"/>
-              <a:t>11/13/2023</a:t>
+              <a:t>11/14/2023</a:t>
             </a:fld>
             <a:endParaRPr lang="en-US"/>
           </a:p>
@@ -1407,7 +1407,7 @@
           <a:p>
             <a:fld id="{18514EC9-E150-4B7A-9B8E-2980A974DF62}" type="datetimeFigureOut">
               <a:rPr lang="en-US" smtClean="0"/>
-              <a:t>11/13/2023</a:t>
+              <a:t>11/14/2023</a:t>
             </a:fld>
             <a:endParaRPr lang="en-US"/>
           </a:p>
@@ -1819,7 +1819,7 @@
           <a:p>
             <a:fld id="{18514EC9-E150-4B7A-9B8E-2980A974DF62}" type="datetimeFigureOut">
               <a:rPr lang="en-US" smtClean="0"/>
-              <a:t>11/13/2023</a:t>
+              <a:t>11/14/2023</a:t>
             </a:fld>
             <a:endParaRPr lang="en-US"/>
           </a:p>
@@ -1960,7 +1960,7 @@
           <a:p>
             <a:fld id="{18514EC9-E150-4B7A-9B8E-2980A974DF62}" type="datetimeFigureOut">
               <a:rPr lang="en-US" smtClean="0"/>
-              <a:t>11/13/2023</a:t>
+              <a:t>11/14/2023</a:t>
             </a:fld>
             <a:endParaRPr lang="en-US"/>
           </a:p>
@@ -2073,7 +2073,7 @@
           <a:p>
             <a:fld id="{18514EC9-E150-4B7A-9B8E-2980A974DF62}" type="datetimeFigureOut">
               <a:rPr lang="en-US" smtClean="0"/>
-              <a:t>11/13/2023</a:t>
+              <a:t>11/14/2023</a:t>
             </a:fld>
             <a:endParaRPr lang="en-US"/>
           </a:p>
@@ -2384,7 +2384,7 @@
           <a:p>
             <a:fld id="{18514EC9-E150-4B7A-9B8E-2980A974DF62}" type="datetimeFigureOut">
               <a:rPr lang="en-US" smtClean="0"/>
-              <a:t>11/13/2023</a:t>
+              <a:t>11/14/2023</a:t>
             </a:fld>
             <a:endParaRPr lang="en-US"/>
           </a:p>
@@ -2672,7 +2672,7 @@
           <a:p>
             <a:fld id="{18514EC9-E150-4B7A-9B8E-2980A974DF62}" type="datetimeFigureOut">
               <a:rPr lang="en-US" smtClean="0"/>
-              <a:t>11/13/2023</a:t>
+              <a:t>11/14/2023</a:t>
             </a:fld>
             <a:endParaRPr lang="en-US"/>
           </a:p>
@@ -2913,7 +2913,7 @@
           <a:p>
             <a:fld id="{18514EC9-E150-4B7A-9B8E-2980A974DF62}" type="datetimeFigureOut">
               <a:rPr lang="en-US" smtClean="0"/>
-              <a:t>11/13/2023</a:t>
+              <a:t>11/14/2023</a:t>
             </a:fld>
             <a:endParaRPr lang="en-US"/>
           </a:p>
@@ -4679,8 +4679,13 @@
             <a:pPr algn="ctr"/>
             <a:r>
               <a:rPr lang="en-US" dirty="0"/>
-              <a:t>EVIMO for Object Detection 11/13</a:t>
-            </a:r>
+              <a:t>EVIMO for Object </a:t>
+            </a:r>
+            <a:r>
+              <a:rPr lang="en-US"/>
+              <a:t>Detection 11/14</a:t>
+            </a:r>
+            <a:endParaRPr lang="en-US" dirty="0"/>
           </a:p>
         </p:txBody>
       </p:sp>
@@ -4801,6 +4806,88 @@
           </a:prstGeom>
         </p:spPr>
       </p:pic>
+      <p:sp>
+        <p:nvSpPr>
+          <p:cNvPr id="4" name="Rectangle 3">
+            <a:extLst>
+              <a:ext uri="{FF2B5EF4-FFF2-40B4-BE49-F238E27FC236}">
+                <a16:creationId xmlns:a16="http://schemas.microsoft.com/office/drawing/2014/main" id="{FEB7DBEF-A244-D0C3-AB25-B405D3EB663D}"/>
+              </a:ext>
+            </a:extLst>
+          </p:cNvPr>
+          <p:cNvSpPr/>
+          <p:nvPr/>
+        </p:nvSpPr>
+        <p:spPr>
+          <a:xfrm>
+            <a:off x="5791200" y="3278909"/>
+            <a:ext cx="5809673" cy="1040571"/>
+          </a:xfrm>
+          <a:prstGeom prst="rect">
+            <a:avLst/>
+          </a:prstGeom>
+          <a:noFill/>
+        </p:spPr>
+        <p:style>
+          <a:lnRef idx="2">
+            <a:schemeClr val="accent1">
+              <a:shade val="15000"/>
+            </a:schemeClr>
+          </a:lnRef>
+          <a:fillRef idx="1">
+            <a:schemeClr val="accent1"/>
+          </a:fillRef>
+          <a:effectRef idx="0">
+            <a:schemeClr val="accent1"/>
+          </a:effectRef>
+          <a:fontRef idx="minor">
+            <a:schemeClr val="lt1"/>
+          </a:fontRef>
+        </p:style>
+        <p:txBody>
+          <a:bodyPr rtlCol="0" anchor="ctr"/>
+          <a:lstStyle/>
+          <a:p>
+            <a:pPr algn="ctr"/>
+            <a:endParaRPr lang="en-US"/>
+          </a:p>
+        </p:txBody>
+      </p:sp>
+      <p:sp>
+        <p:nvSpPr>
+          <p:cNvPr id="6" name="TextBox 5">
+            <a:extLst>
+              <a:ext uri="{FF2B5EF4-FFF2-40B4-BE49-F238E27FC236}">
+                <a16:creationId xmlns:a16="http://schemas.microsoft.com/office/drawing/2014/main" id="{FDD2E5F6-72F7-B0F7-581B-F6A7EFDBDA10}"/>
+              </a:ext>
+            </a:extLst>
+          </p:cNvPr>
+          <p:cNvSpPr txBox="1"/>
+          <p:nvPr/>
+        </p:nvSpPr>
+        <p:spPr>
+          <a:xfrm>
+            <a:off x="6351154" y="4858326"/>
+            <a:ext cx="4689764" cy="307777"/>
+          </a:xfrm>
+          <a:prstGeom prst="rect">
+            <a:avLst/>
+          </a:prstGeom>
+          <a:noFill/>
+        </p:spPr>
+        <p:txBody>
+          <a:bodyPr wrap="square" rtlCol="0">
+            <a:spAutoFit/>
+          </a:bodyPr>
+          <a:lstStyle/>
+          <a:p>
+            <a:r>
+              <a:rPr lang="en-US" sz="1400" dirty="0"/>
+              <a:t>Implementation of loss function for object detection model?</a:t>
+            </a:r>
+          </a:p>
+        </p:txBody>
+      </p:sp>
     </p:spTree>
     <p:extLst>
       <p:ext uri="{BB962C8B-B14F-4D97-AF65-F5344CB8AC3E}">

</xml_diff>

<commit_message>
Adding feedback to ppt
</commit_message>
<xml_diff>
--- a/SNN.pptx
+++ b/SNN.pptx
@@ -4,6 +4,9 @@
   <p:sldMasterIdLst>
     <p:sldMasterId id="2147483648" r:id="rId1"/>
   </p:sldMasterIdLst>
+  <p:notesMasterIdLst>
+    <p:notesMasterId r:id="rId8"/>
+  </p:notesMasterIdLst>
   <p:sldIdLst>
     <p:sldId id="257" r:id="rId2"/>
     <p:sldId id="259" r:id="rId3"/>
@@ -117,6 +120,442 @@
 </p:presentation>
 </file>
 
+<file path=ppt/notesMasters/notesMaster1.xml><?xml version="1.0" encoding="utf-8"?>
+<p:notesMaster xmlns:a="http://schemas.openxmlformats.org/drawingml/2006/main" xmlns:r="http://schemas.openxmlformats.org/officeDocument/2006/relationships" xmlns:p="http://schemas.openxmlformats.org/presentationml/2006/main">
+  <p:cSld>
+    <p:bg>
+      <p:bgRef idx="1001">
+        <a:schemeClr val="bg1"/>
+      </p:bgRef>
+    </p:bg>
+    <p:spTree>
+      <p:nvGrpSpPr>
+        <p:cNvPr id="1" name=""/>
+        <p:cNvGrpSpPr/>
+        <p:nvPr/>
+      </p:nvGrpSpPr>
+      <p:grpSpPr>
+        <a:xfrm>
+          <a:off x="0" y="0"/>
+          <a:ext cx="0" cy="0"/>
+          <a:chOff x="0" y="0"/>
+          <a:chExt cx="0" cy="0"/>
+        </a:xfrm>
+      </p:grpSpPr>
+      <p:sp>
+        <p:nvSpPr>
+          <p:cNvPr id="2" name="Header Placeholder 1"/>
+          <p:cNvSpPr>
+            <a:spLocks noGrp="1"/>
+          </p:cNvSpPr>
+          <p:nvPr>
+            <p:ph type="hdr" sz="quarter"/>
+          </p:nvPr>
+        </p:nvSpPr>
+        <p:spPr>
+          <a:xfrm>
+            <a:off x="0" y="0"/>
+            <a:ext cx="2971800" cy="458788"/>
+          </a:xfrm>
+          <a:prstGeom prst="rect">
+            <a:avLst/>
+          </a:prstGeom>
+        </p:spPr>
+        <p:txBody>
+          <a:bodyPr vert="horz" lIns="91440" tIns="45720" rIns="91440" bIns="45720" rtlCol="0"/>
+          <a:lstStyle>
+            <a:lvl1pPr algn="l">
+              <a:defRPr sz="1200"/>
+            </a:lvl1pPr>
+          </a:lstStyle>
+          <a:p>
+            <a:endParaRPr lang="en-US"/>
+          </a:p>
+        </p:txBody>
+      </p:sp>
+      <p:sp>
+        <p:nvSpPr>
+          <p:cNvPr id="3" name="Date Placeholder 2"/>
+          <p:cNvSpPr>
+            <a:spLocks noGrp="1"/>
+          </p:cNvSpPr>
+          <p:nvPr>
+            <p:ph type="dt" idx="1"/>
+          </p:nvPr>
+        </p:nvSpPr>
+        <p:spPr>
+          <a:xfrm>
+            <a:off x="3884613" y="0"/>
+            <a:ext cx="2971800" cy="458788"/>
+          </a:xfrm>
+          <a:prstGeom prst="rect">
+            <a:avLst/>
+          </a:prstGeom>
+        </p:spPr>
+        <p:txBody>
+          <a:bodyPr vert="horz" lIns="91440" tIns="45720" rIns="91440" bIns="45720" rtlCol="0"/>
+          <a:lstStyle>
+            <a:lvl1pPr algn="r">
+              <a:defRPr sz="1200"/>
+            </a:lvl1pPr>
+          </a:lstStyle>
+          <a:p>
+            <a:fld id="{150B3D5C-D1EE-4E26-9CA0-4C228FFABB9C}" type="datetimeFigureOut">
+              <a:rPr lang="en-US" smtClean="0"/>
+              <a:t>11/28/2023</a:t>
+            </a:fld>
+            <a:endParaRPr lang="en-US"/>
+          </a:p>
+        </p:txBody>
+      </p:sp>
+      <p:sp>
+        <p:nvSpPr>
+          <p:cNvPr id="4" name="Slide Image Placeholder 3"/>
+          <p:cNvSpPr>
+            <a:spLocks noGrp="1" noRot="1" noChangeAspect="1"/>
+          </p:cNvSpPr>
+          <p:nvPr>
+            <p:ph type="sldImg" idx="2"/>
+          </p:nvPr>
+        </p:nvSpPr>
+        <p:spPr>
+          <a:xfrm>
+            <a:off x="685800" y="1143000"/>
+            <a:ext cx="5486400" cy="3086100"/>
+          </a:xfrm>
+          <a:prstGeom prst="rect">
+            <a:avLst/>
+          </a:prstGeom>
+          <a:noFill/>
+          <a:ln w="12700">
+            <a:solidFill>
+              <a:prstClr val="black"/>
+            </a:solidFill>
+          </a:ln>
+        </p:spPr>
+        <p:txBody>
+          <a:bodyPr vert="horz" lIns="91440" tIns="45720" rIns="91440" bIns="45720" rtlCol="0" anchor="ctr"/>
+          <a:lstStyle/>
+          <a:p>
+            <a:endParaRPr lang="en-US"/>
+          </a:p>
+        </p:txBody>
+      </p:sp>
+      <p:sp>
+        <p:nvSpPr>
+          <p:cNvPr id="5" name="Notes Placeholder 4"/>
+          <p:cNvSpPr>
+            <a:spLocks noGrp="1"/>
+          </p:cNvSpPr>
+          <p:nvPr>
+            <p:ph type="body" sz="quarter" idx="3"/>
+          </p:nvPr>
+        </p:nvSpPr>
+        <p:spPr>
+          <a:xfrm>
+            <a:off x="685800" y="4400550"/>
+            <a:ext cx="5486400" cy="3600450"/>
+          </a:xfrm>
+          <a:prstGeom prst="rect">
+            <a:avLst/>
+          </a:prstGeom>
+        </p:spPr>
+        <p:txBody>
+          <a:bodyPr vert="horz" lIns="91440" tIns="45720" rIns="91440" bIns="45720" rtlCol="0"/>
+          <a:lstStyle/>
+          <a:p>
+            <a:pPr lvl="0"/>
+            <a:r>
+              <a:rPr lang="en-US"/>
+              <a:t>Click to edit Master text styles</a:t>
+            </a:r>
+          </a:p>
+          <a:p>
+            <a:pPr lvl="1"/>
+            <a:r>
+              <a:rPr lang="en-US"/>
+              <a:t>Second level</a:t>
+            </a:r>
+          </a:p>
+          <a:p>
+            <a:pPr lvl="2"/>
+            <a:r>
+              <a:rPr lang="en-US"/>
+              <a:t>Third level</a:t>
+            </a:r>
+          </a:p>
+          <a:p>
+            <a:pPr lvl="3"/>
+            <a:r>
+              <a:rPr lang="en-US"/>
+              <a:t>Fourth level</a:t>
+            </a:r>
+          </a:p>
+          <a:p>
+            <a:pPr lvl="4"/>
+            <a:r>
+              <a:rPr lang="en-US"/>
+              <a:t>Fifth level</a:t>
+            </a:r>
+          </a:p>
+        </p:txBody>
+      </p:sp>
+      <p:sp>
+        <p:nvSpPr>
+          <p:cNvPr id="6" name="Footer Placeholder 5"/>
+          <p:cNvSpPr>
+            <a:spLocks noGrp="1"/>
+          </p:cNvSpPr>
+          <p:nvPr>
+            <p:ph type="ftr" sz="quarter" idx="4"/>
+          </p:nvPr>
+        </p:nvSpPr>
+        <p:spPr>
+          <a:xfrm>
+            <a:off x="0" y="8685213"/>
+            <a:ext cx="2971800" cy="458787"/>
+          </a:xfrm>
+          <a:prstGeom prst="rect">
+            <a:avLst/>
+          </a:prstGeom>
+        </p:spPr>
+        <p:txBody>
+          <a:bodyPr vert="horz" lIns="91440" tIns="45720" rIns="91440" bIns="45720" rtlCol="0" anchor="b"/>
+          <a:lstStyle>
+            <a:lvl1pPr algn="l">
+              <a:defRPr sz="1200"/>
+            </a:lvl1pPr>
+          </a:lstStyle>
+          <a:p>
+            <a:endParaRPr lang="en-US"/>
+          </a:p>
+        </p:txBody>
+      </p:sp>
+      <p:sp>
+        <p:nvSpPr>
+          <p:cNvPr id="7" name="Slide Number Placeholder 6"/>
+          <p:cNvSpPr>
+            <a:spLocks noGrp="1"/>
+          </p:cNvSpPr>
+          <p:nvPr>
+            <p:ph type="sldNum" sz="quarter" idx="5"/>
+          </p:nvPr>
+        </p:nvSpPr>
+        <p:spPr>
+          <a:xfrm>
+            <a:off x="3884613" y="8685213"/>
+            <a:ext cx="2971800" cy="458787"/>
+          </a:xfrm>
+          <a:prstGeom prst="rect">
+            <a:avLst/>
+          </a:prstGeom>
+        </p:spPr>
+        <p:txBody>
+          <a:bodyPr vert="horz" lIns="91440" tIns="45720" rIns="91440" bIns="45720" rtlCol="0" anchor="b"/>
+          <a:lstStyle>
+            <a:lvl1pPr algn="r">
+              <a:defRPr sz="1200"/>
+            </a:lvl1pPr>
+          </a:lstStyle>
+          <a:p>
+            <a:fld id="{E54B2C25-0B7E-426C-97E6-805A07563A28}" type="slidenum">
+              <a:rPr lang="en-US" smtClean="0"/>
+              <a:t>‹#›</a:t>
+            </a:fld>
+            <a:endParaRPr lang="en-US"/>
+          </a:p>
+        </p:txBody>
+      </p:sp>
+    </p:spTree>
+    <p:extLst>
+      <p:ext uri="{BB962C8B-B14F-4D97-AF65-F5344CB8AC3E}">
+        <p14:creationId xmlns:p14="http://schemas.microsoft.com/office/powerpoint/2010/main" val="233032893"/>
+      </p:ext>
+    </p:extLst>
+  </p:cSld>
+  <p:clrMap bg1="lt1" tx1="dk1" bg2="lt2" tx2="dk2" accent1="accent1" accent2="accent2" accent3="accent3" accent4="accent4" accent5="accent5" accent6="accent6" hlink="hlink" folHlink="folHlink"/>
+  <p:notesStyle>
+    <a:lvl1pPr marL="0" algn="l" defTabSz="914400" rtl="0" eaLnBrk="1" latinLnBrk="0" hangingPunct="1">
+      <a:defRPr sz="1200" kern="1200">
+        <a:solidFill>
+          <a:schemeClr val="tx1"/>
+        </a:solidFill>
+        <a:latin typeface="+mn-lt"/>
+        <a:ea typeface="+mn-ea"/>
+        <a:cs typeface="+mn-cs"/>
+      </a:defRPr>
+    </a:lvl1pPr>
+    <a:lvl2pPr marL="457200" algn="l" defTabSz="914400" rtl="0" eaLnBrk="1" latinLnBrk="0" hangingPunct="1">
+      <a:defRPr sz="1200" kern="1200">
+        <a:solidFill>
+          <a:schemeClr val="tx1"/>
+        </a:solidFill>
+        <a:latin typeface="+mn-lt"/>
+        <a:ea typeface="+mn-ea"/>
+        <a:cs typeface="+mn-cs"/>
+      </a:defRPr>
+    </a:lvl2pPr>
+    <a:lvl3pPr marL="914400" algn="l" defTabSz="914400" rtl="0" eaLnBrk="1" latinLnBrk="0" hangingPunct="1">
+      <a:defRPr sz="1200" kern="1200">
+        <a:solidFill>
+          <a:schemeClr val="tx1"/>
+        </a:solidFill>
+        <a:latin typeface="+mn-lt"/>
+        <a:ea typeface="+mn-ea"/>
+        <a:cs typeface="+mn-cs"/>
+      </a:defRPr>
+    </a:lvl3pPr>
+    <a:lvl4pPr marL="1371600" algn="l" defTabSz="914400" rtl="0" eaLnBrk="1" latinLnBrk="0" hangingPunct="1">
+      <a:defRPr sz="1200" kern="1200">
+        <a:solidFill>
+          <a:schemeClr val="tx1"/>
+        </a:solidFill>
+        <a:latin typeface="+mn-lt"/>
+        <a:ea typeface="+mn-ea"/>
+        <a:cs typeface="+mn-cs"/>
+      </a:defRPr>
+    </a:lvl4pPr>
+    <a:lvl5pPr marL="1828800" algn="l" defTabSz="914400" rtl="0" eaLnBrk="1" latinLnBrk="0" hangingPunct="1">
+      <a:defRPr sz="1200" kern="1200">
+        <a:solidFill>
+          <a:schemeClr val="tx1"/>
+        </a:solidFill>
+        <a:latin typeface="+mn-lt"/>
+        <a:ea typeface="+mn-ea"/>
+        <a:cs typeface="+mn-cs"/>
+      </a:defRPr>
+    </a:lvl5pPr>
+    <a:lvl6pPr marL="2286000" algn="l" defTabSz="914400" rtl="0" eaLnBrk="1" latinLnBrk="0" hangingPunct="1">
+      <a:defRPr sz="1200" kern="1200">
+        <a:solidFill>
+          <a:schemeClr val="tx1"/>
+        </a:solidFill>
+        <a:latin typeface="+mn-lt"/>
+        <a:ea typeface="+mn-ea"/>
+        <a:cs typeface="+mn-cs"/>
+      </a:defRPr>
+    </a:lvl6pPr>
+    <a:lvl7pPr marL="2743200" algn="l" defTabSz="914400" rtl="0" eaLnBrk="1" latinLnBrk="0" hangingPunct="1">
+      <a:defRPr sz="1200" kern="1200">
+        <a:solidFill>
+          <a:schemeClr val="tx1"/>
+        </a:solidFill>
+        <a:latin typeface="+mn-lt"/>
+        <a:ea typeface="+mn-ea"/>
+        <a:cs typeface="+mn-cs"/>
+      </a:defRPr>
+    </a:lvl7pPr>
+    <a:lvl8pPr marL="3200400" algn="l" defTabSz="914400" rtl="0" eaLnBrk="1" latinLnBrk="0" hangingPunct="1">
+      <a:defRPr sz="1200" kern="1200">
+        <a:solidFill>
+          <a:schemeClr val="tx1"/>
+        </a:solidFill>
+        <a:latin typeface="+mn-lt"/>
+        <a:ea typeface="+mn-ea"/>
+        <a:cs typeface="+mn-cs"/>
+      </a:defRPr>
+    </a:lvl8pPr>
+    <a:lvl9pPr marL="3657600" algn="l" defTabSz="914400" rtl="0" eaLnBrk="1" latinLnBrk="0" hangingPunct="1">
+      <a:defRPr sz="1200" kern="1200">
+        <a:solidFill>
+          <a:schemeClr val="tx1"/>
+        </a:solidFill>
+        <a:latin typeface="+mn-lt"/>
+        <a:ea typeface="+mn-ea"/>
+        <a:cs typeface="+mn-cs"/>
+      </a:defRPr>
+    </a:lvl9pPr>
+  </p:notesStyle>
+</p:notesMaster>
+</file>
+
+<file path=ppt/notesSlides/notesSlide1.xml><?xml version="1.0" encoding="utf-8"?>
+<p:notes xmlns:a="http://schemas.openxmlformats.org/drawingml/2006/main" xmlns:r="http://schemas.openxmlformats.org/officeDocument/2006/relationships" xmlns:p="http://schemas.openxmlformats.org/presentationml/2006/main">
+  <p:cSld>
+    <p:spTree>
+      <p:nvGrpSpPr>
+        <p:cNvPr id="1" name=""/>
+        <p:cNvGrpSpPr/>
+        <p:nvPr/>
+      </p:nvGrpSpPr>
+      <p:grpSpPr>
+        <a:xfrm>
+          <a:off x="0" y="0"/>
+          <a:ext cx="0" cy="0"/>
+          <a:chOff x="0" y="0"/>
+          <a:chExt cx="0" cy="0"/>
+        </a:xfrm>
+      </p:grpSpPr>
+      <p:sp>
+        <p:nvSpPr>
+          <p:cNvPr id="2" name="Slide Image Placeholder 1"/>
+          <p:cNvSpPr>
+            <a:spLocks noGrp="1" noRot="1" noChangeAspect="1"/>
+          </p:cNvSpPr>
+          <p:nvPr>
+            <p:ph type="sldImg"/>
+          </p:nvPr>
+        </p:nvSpPr>
+        <p:spPr/>
+      </p:sp>
+      <p:sp>
+        <p:nvSpPr>
+          <p:cNvPr id="3" name="Notes Placeholder 2"/>
+          <p:cNvSpPr>
+            <a:spLocks noGrp="1"/>
+          </p:cNvSpPr>
+          <p:nvPr>
+            <p:ph type="body" idx="1"/>
+          </p:nvPr>
+        </p:nvSpPr>
+        <p:spPr/>
+        <p:txBody>
+          <a:bodyPr/>
+          <a:lstStyle/>
+          <a:p>
+            <a:r>
+              <a:rPr lang="en-US" dirty="0"/>
+              <a:t>Look into object detection for spiking neural network papers</a:t>
+            </a:r>
+          </a:p>
+        </p:txBody>
+      </p:sp>
+      <p:sp>
+        <p:nvSpPr>
+          <p:cNvPr id="4" name="Slide Number Placeholder 3"/>
+          <p:cNvSpPr>
+            <a:spLocks noGrp="1"/>
+          </p:cNvSpPr>
+          <p:nvPr>
+            <p:ph type="sldNum" sz="quarter" idx="5"/>
+          </p:nvPr>
+        </p:nvSpPr>
+        <p:spPr/>
+        <p:txBody>
+          <a:bodyPr/>
+          <a:lstStyle/>
+          <a:p>
+            <a:fld id="{E54B2C25-0B7E-426C-97E6-805A07563A28}" type="slidenum">
+              <a:rPr lang="en-US" smtClean="0"/>
+              <a:t>6</a:t>
+            </a:fld>
+            <a:endParaRPr lang="en-US"/>
+          </a:p>
+        </p:txBody>
+      </p:sp>
+    </p:spTree>
+    <p:extLst>
+      <p:ext uri="{BB962C8B-B14F-4D97-AF65-F5344CB8AC3E}">
+        <p14:creationId xmlns:p14="http://schemas.microsoft.com/office/powerpoint/2010/main" val="1288863744"/>
+      </p:ext>
+    </p:extLst>
+  </p:cSld>
+  <p:clrMapOvr>
+    <a:masterClrMapping/>
+  </p:clrMapOvr>
+</p:notes>
+</file>
+
 <file path=ppt/slideLayouts/slideLayout1.xml><?xml version="1.0" encoding="utf-8"?>
 <p:sldLayout xmlns:a="http://schemas.openxmlformats.org/drawingml/2006/main" xmlns:r="http://schemas.openxmlformats.org/officeDocument/2006/relationships" xmlns:p="http://schemas.openxmlformats.org/presentationml/2006/main" type="title" preserve="1">
   <p:cSld name="Title Slide">
@@ -264,7 +703,7 @@
           <a:p>
             <a:fld id="{18514EC9-E150-4B7A-9B8E-2980A974DF62}" type="datetimeFigureOut">
               <a:rPr lang="en-US" smtClean="0"/>
-              <a:t>11/27/2023</a:t>
+              <a:t>11/28/2023</a:t>
             </a:fld>
             <a:endParaRPr lang="en-US"/>
           </a:p>
@@ -462,7 +901,7 @@
           <a:p>
             <a:fld id="{18514EC9-E150-4B7A-9B8E-2980A974DF62}" type="datetimeFigureOut">
               <a:rPr lang="en-US" smtClean="0"/>
-              <a:t>11/27/2023</a:t>
+              <a:t>11/28/2023</a:t>
             </a:fld>
             <a:endParaRPr lang="en-US"/>
           </a:p>
@@ -670,7 +1109,7 @@
           <a:p>
             <a:fld id="{18514EC9-E150-4B7A-9B8E-2980A974DF62}" type="datetimeFigureOut">
               <a:rPr lang="en-US" smtClean="0"/>
-              <a:t>11/27/2023</a:t>
+              <a:t>11/28/2023</a:t>
             </a:fld>
             <a:endParaRPr lang="en-US"/>
           </a:p>
@@ -868,7 +1307,7 @@
           <a:p>
             <a:fld id="{18514EC9-E150-4B7A-9B8E-2980A974DF62}" type="datetimeFigureOut">
               <a:rPr lang="en-US" smtClean="0"/>
-              <a:t>11/27/2023</a:t>
+              <a:t>11/28/2023</a:t>
             </a:fld>
             <a:endParaRPr lang="en-US"/>
           </a:p>
@@ -1143,7 +1582,7 @@
           <a:p>
             <a:fld id="{18514EC9-E150-4B7A-9B8E-2980A974DF62}" type="datetimeFigureOut">
               <a:rPr lang="en-US" smtClean="0"/>
-              <a:t>11/27/2023</a:t>
+              <a:t>11/28/2023</a:t>
             </a:fld>
             <a:endParaRPr lang="en-US"/>
           </a:p>
@@ -1408,7 +1847,7 @@
           <a:p>
             <a:fld id="{18514EC9-E150-4B7A-9B8E-2980A974DF62}" type="datetimeFigureOut">
               <a:rPr lang="en-US" smtClean="0"/>
-              <a:t>11/27/2023</a:t>
+              <a:t>11/28/2023</a:t>
             </a:fld>
             <a:endParaRPr lang="en-US"/>
           </a:p>
@@ -1820,7 +2259,7 @@
           <a:p>
             <a:fld id="{18514EC9-E150-4B7A-9B8E-2980A974DF62}" type="datetimeFigureOut">
               <a:rPr lang="en-US" smtClean="0"/>
-              <a:t>11/27/2023</a:t>
+              <a:t>11/28/2023</a:t>
             </a:fld>
             <a:endParaRPr lang="en-US"/>
           </a:p>
@@ -1961,7 +2400,7 @@
           <a:p>
             <a:fld id="{18514EC9-E150-4B7A-9B8E-2980A974DF62}" type="datetimeFigureOut">
               <a:rPr lang="en-US" smtClean="0"/>
-              <a:t>11/27/2023</a:t>
+              <a:t>11/28/2023</a:t>
             </a:fld>
             <a:endParaRPr lang="en-US"/>
           </a:p>
@@ -2074,7 +2513,7 @@
           <a:p>
             <a:fld id="{18514EC9-E150-4B7A-9B8E-2980A974DF62}" type="datetimeFigureOut">
               <a:rPr lang="en-US" smtClean="0"/>
-              <a:t>11/27/2023</a:t>
+              <a:t>11/28/2023</a:t>
             </a:fld>
             <a:endParaRPr lang="en-US"/>
           </a:p>
@@ -2385,7 +2824,7 @@
           <a:p>
             <a:fld id="{18514EC9-E150-4B7A-9B8E-2980A974DF62}" type="datetimeFigureOut">
               <a:rPr lang="en-US" smtClean="0"/>
-              <a:t>11/27/2023</a:t>
+              <a:t>11/28/2023</a:t>
             </a:fld>
             <a:endParaRPr lang="en-US"/>
           </a:p>
@@ -2673,7 +3112,7 @@
           <a:p>
             <a:fld id="{18514EC9-E150-4B7A-9B8E-2980A974DF62}" type="datetimeFigureOut">
               <a:rPr lang="en-US" smtClean="0"/>
-              <a:t>11/27/2023</a:t>
+              <a:t>11/28/2023</a:t>
             </a:fld>
             <a:endParaRPr lang="en-US"/>
           </a:p>
@@ -2914,7 +3353,7 @@
           <a:p>
             <a:fld id="{18514EC9-E150-4B7A-9B8E-2980A974DF62}" type="datetimeFigureOut">
               <a:rPr lang="en-US" smtClean="0"/>
-              <a:t>11/27/2023</a:t>
+              <a:t>11/28/2023</a:t>
             </a:fld>
             <a:endParaRPr lang="en-US"/>
           </a:p>
@@ -5090,6 +5529,14 @@
             <a:pPr lvl="1"/>
             <a:endParaRPr lang="en-US" sz="1600" dirty="0"/>
           </a:p>
+          <a:p>
+            <a:pPr lvl="1"/>
+            <a:endParaRPr lang="en-US" sz="1600" dirty="0"/>
+          </a:p>
+          <a:p>
+            <a:pPr lvl="1"/>
+            <a:endParaRPr lang="en-US" sz="1600" dirty="0"/>
+          </a:p>
         </p:txBody>
       </p:sp>
       <p:pic>
@@ -5107,7 +5554,7 @@
           <p:nvPr/>
         </p:nvPicPr>
         <p:blipFill>
-          <a:blip r:embed="rId2"/>
+          <a:blip r:embed="rId3"/>
           <a:stretch>
             <a:fillRect/>
           </a:stretch>
@@ -5428,4 +5875,299 @@
     </a:ext>
   </a:extLst>
 </a:theme>
+</file>
+
+<file path=ppt/theme/theme2.xml><?xml version="1.0" encoding="utf-8"?>
+<a:theme xmlns:a="http://schemas.openxmlformats.org/drawingml/2006/main" name="Office Theme">
+  <a:themeElements>
+    <a:clrScheme name="Office">
+      <a:dk1>
+        <a:sysClr val="windowText" lastClr="000000"/>
+      </a:dk1>
+      <a:lt1>
+        <a:sysClr val="window" lastClr="FFFFFF"/>
+      </a:lt1>
+      <a:dk2>
+        <a:srgbClr val="44546A"/>
+      </a:dk2>
+      <a:lt2>
+        <a:srgbClr val="E7E6E6"/>
+      </a:lt2>
+      <a:accent1>
+        <a:srgbClr val="4472C4"/>
+      </a:accent1>
+      <a:accent2>
+        <a:srgbClr val="ED7D31"/>
+      </a:accent2>
+      <a:accent3>
+        <a:srgbClr val="A5A5A5"/>
+      </a:accent3>
+      <a:accent4>
+        <a:srgbClr val="FFC000"/>
+      </a:accent4>
+      <a:accent5>
+        <a:srgbClr val="5B9BD5"/>
+      </a:accent5>
+      <a:accent6>
+        <a:srgbClr val="70AD47"/>
+      </a:accent6>
+      <a:hlink>
+        <a:srgbClr val="0563C1"/>
+      </a:hlink>
+      <a:folHlink>
+        <a:srgbClr val="954F72"/>
+      </a:folHlink>
+    </a:clrScheme>
+    <a:fontScheme name="Office">
+      <a:majorFont>
+        <a:latin typeface="Calibri Light" panose="020F0302020204030204"/>
+        <a:ea typeface=""/>
+        <a:cs typeface=""/>
+        <a:font script="Jpan" typeface="游ゴシック Light"/>
+        <a:font script="Hang" typeface="맑은 고딕"/>
+        <a:font script="Hans" typeface="等线 Light"/>
+        <a:font script="Hant" typeface="新細明體"/>
+        <a:font script="Arab" typeface="Times New Roman"/>
+        <a:font script="Hebr" typeface="Times New Roman"/>
+        <a:font script="Thai" typeface="Angsana New"/>
+        <a:font script="Ethi" typeface="Nyala"/>
+        <a:font script="Beng" typeface="Vrinda"/>
+        <a:font script="Gujr" typeface="Shruti"/>
+        <a:font script="Khmr" typeface="MoolBoran"/>
+        <a:font script="Knda" typeface="Tunga"/>
+        <a:font script="Guru" typeface="Raavi"/>
+        <a:font script="Cans" typeface="Euphemia"/>
+        <a:font script="Cher" typeface="Plantagenet Cherokee"/>
+        <a:font script="Yiii" typeface="Microsoft Yi Baiti"/>
+        <a:font script="Tibt" typeface="Microsoft Himalaya"/>
+        <a:font script="Thaa" typeface="MV Boli"/>
+        <a:font script="Deva" typeface="Mangal"/>
+        <a:font script="Telu" typeface="Gautami"/>
+        <a:font script="Taml" typeface="Latha"/>
+        <a:font script="Syrc" typeface="Estrangelo Edessa"/>
+        <a:font script="Orya" typeface="Kalinga"/>
+        <a:font script="Mlym" typeface="Kartika"/>
+        <a:font script="Laoo" typeface="DokChampa"/>
+        <a:font script="Sinh" typeface="Iskoola Pota"/>
+        <a:font script="Mong" typeface="Mongolian Baiti"/>
+        <a:font script="Viet" typeface="Times New Roman"/>
+        <a:font script="Uigh" typeface="Microsoft Uighur"/>
+        <a:font script="Geor" typeface="Sylfaen"/>
+        <a:font script="Armn" typeface="Arial"/>
+        <a:font script="Bugi" typeface="Leelawadee UI"/>
+        <a:font script="Bopo" typeface="Microsoft JhengHei"/>
+        <a:font script="Java" typeface="Javanese Text"/>
+        <a:font script="Lisu" typeface="Segoe UI"/>
+        <a:font script="Mymr" typeface="Myanmar Text"/>
+        <a:font script="Nkoo" typeface="Ebrima"/>
+        <a:font script="Olck" typeface="Nirmala UI"/>
+        <a:font script="Osma" typeface="Ebrima"/>
+        <a:font script="Phag" typeface="Phagspa"/>
+        <a:font script="Syrn" typeface="Estrangelo Edessa"/>
+        <a:font script="Syrj" typeface="Estrangelo Edessa"/>
+        <a:font script="Syre" typeface="Estrangelo Edessa"/>
+        <a:font script="Sora" typeface="Nirmala UI"/>
+        <a:font script="Tale" typeface="Microsoft Tai Le"/>
+        <a:font script="Talu" typeface="Microsoft New Tai Lue"/>
+        <a:font script="Tfng" typeface="Ebrima"/>
+      </a:majorFont>
+      <a:minorFont>
+        <a:latin typeface="Calibri" panose="020F0502020204030204"/>
+        <a:ea typeface=""/>
+        <a:cs typeface=""/>
+        <a:font script="Jpan" typeface="游ゴシック"/>
+        <a:font script="Hang" typeface="맑은 고딕"/>
+        <a:font script="Hans" typeface="等线"/>
+        <a:font script="Hant" typeface="新細明體"/>
+        <a:font script="Arab" typeface="Arial"/>
+        <a:font script="Hebr" typeface="Arial"/>
+        <a:font script="Thai" typeface="Cordia New"/>
+        <a:font script="Ethi" typeface="Nyala"/>
+        <a:font script="Beng" typeface="Vrinda"/>
+        <a:font script="Gujr" typeface="Shruti"/>
+        <a:font script="Khmr" typeface="DaunPenh"/>
+        <a:font script="Knda" typeface="Tunga"/>
+        <a:font script="Guru" typeface="Raavi"/>
+        <a:font script="Cans" typeface="Euphemia"/>
+        <a:font script="Cher" typeface="Plantagenet Cherokee"/>
+        <a:font script="Yiii" typeface="Microsoft Yi Baiti"/>
+        <a:font script="Tibt" typeface="Microsoft Himalaya"/>
+        <a:font script="Thaa" typeface="MV Boli"/>
+        <a:font script="Deva" typeface="Mangal"/>
+        <a:font script="Telu" typeface="Gautami"/>
+        <a:font script="Taml" typeface="Latha"/>
+        <a:font script="Syrc" typeface="Estrangelo Edessa"/>
+        <a:font script="Orya" typeface="Kalinga"/>
+        <a:font script="Mlym" typeface="Kartika"/>
+        <a:font script="Laoo" typeface="DokChampa"/>
+        <a:font script="Sinh" typeface="Iskoola Pota"/>
+        <a:font script="Mong" typeface="Mongolian Baiti"/>
+        <a:font script="Viet" typeface="Arial"/>
+        <a:font script="Uigh" typeface="Microsoft Uighur"/>
+        <a:font script="Geor" typeface="Sylfaen"/>
+        <a:font script="Armn" typeface="Arial"/>
+        <a:font script="Bugi" typeface="Leelawadee UI"/>
+        <a:font script="Bopo" typeface="Microsoft JhengHei"/>
+        <a:font script="Java" typeface="Javanese Text"/>
+        <a:font script="Lisu" typeface="Segoe UI"/>
+        <a:font script="Mymr" typeface="Myanmar Text"/>
+        <a:font script="Nkoo" typeface="Ebrima"/>
+        <a:font script="Olck" typeface="Nirmala UI"/>
+        <a:font script="Osma" typeface="Ebrima"/>
+        <a:font script="Phag" typeface="Phagspa"/>
+        <a:font script="Syrn" typeface="Estrangelo Edessa"/>
+        <a:font script="Syrj" typeface="Estrangelo Edessa"/>
+        <a:font script="Syre" typeface="Estrangelo Edessa"/>
+        <a:font script="Sora" typeface="Nirmala UI"/>
+        <a:font script="Tale" typeface="Microsoft Tai Le"/>
+        <a:font script="Talu" typeface="Microsoft New Tai Lue"/>
+        <a:font script="Tfng" typeface="Ebrima"/>
+      </a:minorFont>
+    </a:fontScheme>
+    <a:fmtScheme name="Office">
+      <a:fillStyleLst>
+        <a:solidFill>
+          <a:schemeClr val="phClr"/>
+        </a:solidFill>
+        <a:gradFill rotWithShape="1">
+          <a:gsLst>
+            <a:gs pos="0">
+              <a:schemeClr val="phClr">
+                <a:lumMod val="110000"/>
+                <a:satMod val="105000"/>
+                <a:tint val="67000"/>
+              </a:schemeClr>
+            </a:gs>
+            <a:gs pos="50000">
+              <a:schemeClr val="phClr">
+                <a:lumMod val="105000"/>
+                <a:satMod val="103000"/>
+                <a:tint val="73000"/>
+              </a:schemeClr>
+            </a:gs>
+            <a:gs pos="100000">
+              <a:schemeClr val="phClr">
+                <a:lumMod val="105000"/>
+                <a:satMod val="109000"/>
+                <a:tint val="81000"/>
+              </a:schemeClr>
+            </a:gs>
+          </a:gsLst>
+          <a:lin ang="5400000" scaled="0"/>
+        </a:gradFill>
+        <a:gradFill rotWithShape="1">
+          <a:gsLst>
+            <a:gs pos="0">
+              <a:schemeClr val="phClr">
+                <a:satMod val="103000"/>
+                <a:lumMod val="102000"/>
+                <a:tint val="94000"/>
+              </a:schemeClr>
+            </a:gs>
+            <a:gs pos="50000">
+              <a:schemeClr val="phClr">
+                <a:satMod val="110000"/>
+                <a:lumMod val="100000"/>
+                <a:shade val="100000"/>
+              </a:schemeClr>
+            </a:gs>
+            <a:gs pos="100000">
+              <a:schemeClr val="phClr">
+                <a:lumMod val="99000"/>
+                <a:satMod val="120000"/>
+                <a:shade val="78000"/>
+              </a:schemeClr>
+            </a:gs>
+          </a:gsLst>
+          <a:lin ang="5400000" scaled="0"/>
+        </a:gradFill>
+      </a:fillStyleLst>
+      <a:lnStyleLst>
+        <a:ln w="6350" cap="flat" cmpd="sng" algn="ctr">
+          <a:solidFill>
+            <a:schemeClr val="phClr"/>
+          </a:solidFill>
+          <a:prstDash val="solid"/>
+          <a:miter lim="800000"/>
+        </a:ln>
+        <a:ln w="12700" cap="flat" cmpd="sng" algn="ctr">
+          <a:solidFill>
+            <a:schemeClr val="phClr"/>
+          </a:solidFill>
+          <a:prstDash val="solid"/>
+          <a:miter lim="800000"/>
+        </a:ln>
+        <a:ln w="19050" cap="flat" cmpd="sng" algn="ctr">
+          <a:solidFill>
+            <a:schemeClr val="phClr"/>
+          </a:solidFill>
+          <a:prstDash val="solid"/>
+          <a:miter lim="800000"/>
+        </a:ln>
+      </a:lnStyleLst>
+      <a:effectStyleLst>
+        <a:effectStyle>
+          <a:effectLst/>
+        </a:effectStyle>
+        <a:effectStyle>
+          <a:effectLst/>
+        </a:effectStyle>
+        <a:effectStyle>
+          <a:effectLst>
+            <a:outerShdw blurRad="57150" dist="19050" dir="5400000" algn="ctr" rotWithShape="0">
+              <a:srgbClr val="000000">
+                <a:alpha val="63000"/>
+              </a:srgbClr>
+            </a:outerShdw>
+          </a:effectLst>
+        </a:effectStyle>
+      </a:effectStyleLst>
+      <a:bgFillStyleLst>
+        <a:solidFill>
+          <a:schemeClr val="phClr"/>
+        </a:solidFill>
+        <a:solidFill>
+          <a:schemeClr val="phClr">
+            <a:tint val="95000"/>
+            <a:satMod val="170000"/>
+          </a:schemeClr>
+        </a:solidFill>
+        <a:gradFill rotWithShape="1">
+          <a:gsLst>
+            <a:gs pos="0">
+              <a:schemeClr val="phClr">
+                <a:tint val="93000"/>
+                <a:satMod val="150000"/>
+                <a:shade val="98000"/>
+                <a:lumMod val="102000"/>
+              </a:schemeClr>
+            </a:gs>
+            <a:gs pos="50000">
+              <a:schemeClr val="phClr">
+                <a:tint val="98000"/>
+                <a:satMod val="130000"/>
+                <a:shade val="90000"/>
+                <a:lumMod val="103000"/>
+              </a:schemeClr>
+            </a:gs>
+            <a:gs pos="100000">
+              <a:schemeClr val="phClr">
+                <a:shade val="63000"/>
+                <a:satMod val="120000"/>
+              </a:schemeClr>
+            </a:gs>
+          </a:gsLst>
+          <a:lin ang="5400000" scaled="0"/>
+        </a:gradFill>
+      </a:bgFillStyleLst>
+    </a:fmtScheme>
+  </a:themeElements>
+  <a:objectDefaults/>
+  <a:extraClrSchemeLst/>
+  <a:extLst>
+    <a:ext uri="{05A4C25C-085E-4340-85A3-A5531E510DB2}">
+      <thm15:themeFamily xmlns:thm15="http://schemas.microsoft.com/office/thememl/2012/main" name="Office Theme" id="{62F939B6-93AF-4DB8-9C6B-D6C7DFDC589F}" vid="{4A3C46E8-61CC-4603-A589-7422A47A8E4A}"/>
+    </a:ext>
+  </a:extLst>
+</a:theme>
 </file>
</xml_diff>

<commit_message>
Commit for 12/5 meeting
</commit_message>
<xml_diff>
--- a/SNN.pptx
+++ b/SNN.pptx
@@ -11,6 +11,7 @@
     <p:sldId id="261" r:id="rId5"/>
     <p:sldId id="262" r:id="rId6"/>
     <p:sldId id="263" r:id="rId7"/>
+    <p:sldId id="264" r:id="rId8"/>
   </p:sldIdLst>
   <p:sldSz cx="12192000" cy="6858000"/>
   <p:notesSz cx="6858000" cy="9144000"/>
@@ -264,7 +265,7 @@
           <a:p>
             <a:fld id="{18514EC9-E150-4B7A-9B8E-2980A974DF62}" type="datetimeFigureOut">
               <a:rPr lang="en-US" smtClean="0"/>
-              <a:t>11/27/2023</a:t>
+              <a:t>12/4/2023</a:t>
             </a:fld>
             <a:endParaRPr lang="en-US"/>
           </a:p>
@@ -462,7 +463,7 @@
           <a:p>
             <a:fld id="{18514EC9-E150-4B7A-9B8E-2980A974DF62}" type="datetimeFigureOut">
               <a:rPr lang="en-US" smtClean="0"/>
-              <a:t>11/27/2023</a:t>
+              <a:t>12/4/2023</a:t>
             </a:fld>
             <a:endParaRPr lang="en-US"/>
           </a:p>
@@ -670,7 +671,7 @@
           <a:p>
             <a:fld id="{18514EC9-E150-4B7A-9B8E-2980A974DF62}" type="datetimeFigureOut">
               <a:rPr lang="en-US" smtClean="0"/>
-              <a:t>11/27/2023</a:t>
+              <a:t>12/4/2023</a:t>
             </a:fld>
             <a:endParaRPr lang="en-US"/>
           </a:p>
@@ -868,7 +869,7 @@
           <a:p>
             <a:fld id="{18514EC9-E150-4B7A-9B8E-2980A974DF62}" type="datetimeFigureOut">
               <a:rPr lang="en-US" smtClean="0"/>
-              <a:t>11/27/2023</a:t>
+              <a:t>12/4/2023</a:t>
             </a:fld>
             <a:endParaRPr lang="en-US"/>
           </a:p>
@@ -1143,7 +1144,7 @@
           <a:p>
             <a:fld id="{18514EC9-E150-4B7A-9B8E-2980A974DF62}" type="datetimeFigureOut">
               <a:rPr lang="en-US" smtClean="0"/>
-              <a:t>11/27/2023</a:t>
+              <a:t>12/4/2023</a:t>
             </a:fld>
             <a:endParaRPr lang="en-US"/>
           </a:p>
@@ -1408,7 +1409,7 @@
           <a:p>
             <a:fld id="{18514EC9-E150-4B7A-9B8E-2980A974DF62}" type="datetimeFigureOut">
               <a:rPr lang="en-US" smtClean="0"/>
-              <a:t>11/27/2023</a:t>
+              <a:t>12/4/2023</a:t>
             </a:fld>
             <a:endParaRPr lang="en-US"/>
           </a:p>
@@ -1820,7 +1821,7 @@
           <a:p>
             <a:fld id="{18514EC9-E150-4B7A-9B8E-2980A974DF62}" type="datetimeFigureOut">
               <a:rPr lang="en-US" smtClean="0"/>
-              <a:t>11/27/2023</a:t>
+              <a:t>12/4/2023</a:t>
             </a:fld>
             <a:endParaRPr lang="en-US"/>
           </a:p>
@@ -1961,7 +1962,7 @@
           <a:p>
             <a:fld id="{18514EC9-E150-4B7A-9B8E-2980A974DF62}" type="datetimeFigureOut">
               <a:rPr lang="en-US" smtClean="0"/>
-              <a:t>11/27/2023</a:t>
+              <a:t>12/4/2023</a:t>
             </a:fld>
             <a:endParaRPr lang="en-US"/>
           </a:p>
@@ -2074,7 +2075,7 @@
           <a:p>
             <a:fld id="{18514EC9-E150-4B7A-9B8E-2980A974DF62}" type="datetimeFigureOut">
               <a:rPr lang="en-US" smtClean="0"/>
-              <a:t>11/27/2023</a:t>
+              <a:t>12/4/2023</a:t>
             </a:fld>
             <a:endParaRPr lang="en-US"/>
           </a:p>
@@ -2385,7 +2386,7 @@
           <a:p>
             <a:fld id="{18514EC9-E150-4B7A-9B8E-2980A974DF62}" type="datetimeFigureOut">
               <a:rPr lang="en-US" smtClean="0"/>
-              <a:t>11/27/2023</a:t>
+              <a:t>12/4/2023</a:t>
             </a:fld>
             <a:endParaRPr lang="en-US"/>
           </a:p>
@@ -2673,7 +2674,7 @@
           <a:p>
             <a:fld id="{18514EC9-E150-4B7A-9B8E-2980A974DF62}" type="datetimeFigureOut">
               <a:rPr lang="en-US" smtClean="0"/>
-              <a:t>11/27/2023</a:t>
+              <a:t>12/4/2023</a:t>
             </a:fld>
             <a:endParaRPr lang="en-US"/>
           </a:p>
@@ -2914,7 +2915,7 @@
           <a:p>
             <a:fld id="{18514EC9-E150-4B7A-9B8E-2980A974DF62}" type="datetimeFigureOut">
               <a:rPr lang="en-US" smtClean="0"/>
-              <a:t>11/27/2023</a:t>
+              <a:t>12/4/2023</a:t>
             </a:fld>
             <a:endParaRPr lang="en-US"/>
           </a:p>
@@ -5135,6 +5136,256 @@
 </p:sld>
 </file>
 
+<file path=ppt/slides/slide7.xml><?xml version="1.0" encoding="utf-8"?>
+<p:sld xmlns:a="http://schemas.openxmlformats.org/drawingml/2006/main" xmlns:r="http://schemas.openxmlformats.org/officeDocument/2006/relationships" xmlns:p="http://schemas.openxmlformats.org/presentationml/2006/main">
+  <p:cSld>
+    <p:spTree>
+      <p:nvGrpSpPr>
+        <p:cNvPr id="1" name=""/>
+        <p:cNvGrpSpPr/>
+        <p:nvPr/>
+      </p:nvGrpSpPr>
+      <p:grpSpPr>
+        <a:xfrm>
+          <a:off x="0" y="0"/>
+          <a:ext cx="0" cy="0"/>
+          <a:chOff x="0" y="0"/>
+          <a:chExt cx="0" cy="0"/>
+        </a:xfrm>
+      </p:grpSpPr>
+      <p:sp>
+        <p:nvSpPr>
+          <p:cNvPr id="2" name="Title 1">
+            <a:extLst>
+              <a:ext uri="{FF2B5EF4-FFF2-40B4-BE49-F238E27FC236}">
+                <a16:creationId xmlns:a16="http://schemas.microsoft.com/office/drawing/2014/main" id="{22763D83-90BE-C86C-9397-A2C168EC54EF}"/>
+              </a:ext>
+            </a:extLst>
+          </p:cNvPr>
+          <p:cNvSpPr>
+            <a:spLocks noGrp="1"/>
+          </p:cNvSpPr>
+          <p:nvPr>
+            <p:ph type="title"/>
+          </p:nvPr>
+        </p:nvSpPr>
+        <p:spPr/>
+        <p:txBody>
+          <a:bodyPr/>
+          <a:lstStyle/>
+          <a:p>
+            <a:pPr algn="ctr"/>
+            <a:r>
+              <a:rPr lang="en-US" dirty="0"/>
+              <a:t>Potential Models for Obj Det 12/5</a:t>
+            </a:r>
+          </a:p>
+        </p:txBody>
+      </p:sp>
+      <p:sp>
+        <p:nvSpPr>
+          <p:cNvPr id="3" name="Content Placeholder 2">
+            <a:extLst>
+              <a:ext uri="{FF2B5EF4-FFF2-40B4-BE49-F238E27FC236}">
+                <a16:creationId xmlns:a16="http://schemas.microsoft.com/office/drawing/2014/main" id="{A8C72B52-E6C2-1778-9EBB-5F5C0285FF10}"/>
+              </a:ext>
+            </a:extLst>
+          </p:cNvPr>
+          <p:cNvSpPr>
+            <a:spLocks noGrp="1"/>
+          </p:cNvSpPr>
+          <p:nvPr>
+            <p:ph idx="1"/>
+          </p:nvPr>
+        </p:nvSpPr>
+        <p:spPr>
+          <a:xfrm>
+            <a:off x="838200" y="1825625"/>
+            <a:ext cx="4102015" cy="4351338"/>
+          </a:xfrm>
+        </p:spPr>
+        <p:txBody>
+          <a:bodyPr/>
+          <a:lstStyle/>
+          <a:p>
+            <a:pPr marL="0" indent="0">
+              <a:buNone/>
+            </a:pPr>
+            <a:r>
+              <a:rPr lang="en-US" sz="2000" dirty="0" err="1"/>
+              <a:t>CenterNet</a:t>
+            </a:r>
+            <a:r>
+              <a:rPr lang="en-US" sz="2000" dirty="0"/>
+              <a:t> (</a:t>
+            </a:r>
+            <a:r>
+              <a:rPr lang="en-US" sz="2000" dirty="0" err="1"/>
+              <a:t>Keypoint</a:t>
+            </a:r>
+            <a:r>
+              <a:rPr lang="en-US" sz="2000" dirty="0"/>
+              <a:t> Triplets):</a:t>
+            </a:r>
+          </a:p>
+          <a:p>
+            <a:pPr lvl="1"/>
+            <a:r>
+              <a:rPr lang="en-US" sz="1600" dirty="0"/>
+              <a:t>Use corners to determine object</a:t>
+            </a:r>
+          </a:p>
+          <a:p>
+            <a:pPr lvl="1"/>
+            <a:r>
+              <a:rPr lang="en-US" sz="1600" dirty="0"/>
+              <a:t>Center point determines class</a:t>
+            </a:r>
+          </a:p>
+          <a:p>
+            <a:pPr lvl="1"/>
+            <a:r>
+              <a:rPr lang="en-US" sz="1600" dirty="0"/>
+              <a:t>No anchor boxes</a:t>
+            </a:r>
+          </a:p>
+          <a:p>
+            <a:pPr lvl="1"/>
+            <a:r>
+              <a:rPr lang="en-US" sz="1600" dirty="0"/>
+              <a:t>Can predict multiple boxes</a:t>
+            </a:r>
+          </a:p>
+          <a:p>
+            <a:pPr lvl="1"/>
+            <a:r>
+              <a:rPr lang="en-US" sz="1600" dirty="0"/>
+              <a:t>Paper used images</a:t>
+            </a:r>
+          </a:p>
+          <a:p>
+            <a:pPr marL="0" indent="0">
+              <a:buNone/>
+            </a:pPr>
+            <a:endParaRPr lang="en-US" sz="1600" dirty="0"/>
+          </a:p>
+          <a:p>
+            <a:pPr marL="0" indent="0">
+              <a:buNone/>
+            </a:pPr>
+            <a:endParaRPr lang="en-US" sz="1600" dirty="0"/>
+          </a:p>
+          <a:p>
+            <a:pPr marL="0" indent="0">
+              <a:buNone/>
+            </a:pPr>
+            <a:r>
+              <a:rPr lang="en-US" sz="2000" dirty="0"/>
+              <a:t>Encoder-Decoder DECOLLE:</a:t>
+            </a:r>
+          </a:p>
+          <a:p>
+            <a:pPr lvl="1"/>
+            <a:r>
+              <a:rPr lang="en-US" sz="1600" dirty="0"/>
+              <a:t>Using bounding boxes</a:t>
+            </a:r>
+          </a:p>
+          <a:p>
+            <a:pPr lvl="1"/>
+            <a:r>
+              <a:rPr lang="en-US" sz="1600" dirty="0"/>
+              <a:t>Only predicts one bounding box</a:t>
+            </a:r>
+          </a:p>
+          <a:p>
+            <a:pPr lvl="1"/>
+            <a:r>
+              <a:rPr lang="en-US" sz="1600" dirty="0"/>
+              <a:t>Paper used events from rate-coded images</a:t>
+            </a:r>
+          </a:p>
+          <a:p>
+            <a:pPr marL="0" indent="0">
+              <a:buNone/>
+            </a:pPr>
+            <a:endParaRPr lang="en-US" sz="2000" dirty="0"/>
+          </a:p>
+        </p:txBody>
+      </p:sp>
+      <p:pic>
+        <p:nvPicPr>
+          <p:cNvPr id="4" name="Picture 3">
+            <a:extLst>
+              <a:ext uri="{FF2B5EF4-FFF2-40B4-BE49-F238E27FC236}">
+                <a16:creationId xmlns:a16="http://schemas.microsoft.com/office/drawing/2014/main" id="{4E3DE35D-9F98-D145-6030-4051D532CD20}"/>
+              </a:ext>
+            </a:extLst>
+          </p:cNvPr>
+          <p:cNvPicPr>
+            <a:picLocks noChangeAspect="1"/>
+          </p:cNvPicPr>
+          <p:nvPr/>
+        </p:nvPicPr>
+        <p:blipFill>
+          <a:blip r:embed="rId2"/>
+          <a:stretch>
+            <a:fillRect/>
+          </a:stretch>
+        </p:blipFill>
+        <p:spPr>
+          <a:xfrm>
+            <a:off x="5219047" y="1690688"/>
+            <a:ext cx="6504100" cy="1700469"/>
+          </a:xfrm>
+          <a:prstGeom prst="rect">
+            <a:avLst/>
+          </a:prstGeom>
+        </p:spPr>
+      </p:pic>
+      <p:pic>
+        <p:nvPicPr>
+          <p:cNvPr id="6" name="Picture 5">
+            <a:extLst>
+              <a:ext uri="{FF2B5EF4-FFF2-40B4-BE49-F238E27FC236}">
+                <a16:creationId xmlns:a16="http://schemas.microsoft.com/office/drawing/2014/main" id="{940B2A77-ADB6-1A7F-B24B-68247496006D}"/>
+              </a:ext>
+            </a:extLst>
+          </p:cNvPr>
+          <p:cNvPicPr>
+            <a:picLocks noChangeAspect="1"/>
+          </p:cNvPicPr>
+          <p:nvPr/>
+        </p:nvPicPr>
+        <p:blipFill>
+          <a:blip r:embed="rId3"/>
+          <a:stretch>
+            <a:fillRect/>
+          </a:stretch>
+        </p:blipFill>
+        <p:spPr>
+          <a:xfrm>
+            <a:off x="5979861" y="3884406"/>
+            <a:ext cx="5085703" cy="2292557"/>
+          </a:xfrm>
+          <a:prstGeom prst="rect">
+            <a:avLst/>
+          </a:prstGeom>
+        </p:spPr>
+      </p:pic>
+    </p:spTree>
+    <p:extLst>
+      <p:ext uri="{BB962C8B-B14F-4D97-AF65-F5344CB8AC3E}">
+        <p14:creationId xmlns:p14="http://schemas.microsoft.com/office/powerpoint/2010/main" val="3082922628"/>
+      </p:ext>
+    </p:extLst>
+  </p:cSld>
+  <p:clrMapOvr>
+    <a:masterClrMapping/>
+  </p:clrMapOvr>
+</p:sld>
+</file>
+
 <file path=ppt/theme/theme1.xml><?xml version="1.0" encoding="utf-8"?>
 <a:theme xmlns:a="http://schemas.openxmlformats.org/drawingml/2006/main" name="Office Theme">
   <a:themeElements>

</xml_diff>

<commit_message>
Initial add of local learning rule to preexisting model
</commit_message>
<xml_diff>
--- a/SNN.pptx
+++ b/SNN.pptx
@@ -5,7 +5,7 @@
     <p:sldMasterId id="2147483648" r:id="rId1"/>
   </p:sldMasterIdLst>
   <p:notesMasterIdLst>
-    <p:notesMasterId r:id="rId10"/>
+    <p:notesMasterId r:id="rId11"/>
   </p:notesMasterIdLst>
   <p:sldIdLst>
     <p:sldId id="257" r:id="rId2"/>
@@ -16,6 +16,7 @@
     <p:sldId id="263" r:id="rId7"/>
     <p:sldId id="264" r:id="rId8"/>
     <p:sldId id="265" r:id="rId9"/>
+    <p:sldId id="266" r:id="rId10"/>
   </p:sldIdLst>
   <p:sldSz cx="12192000" cy="6858000"/>
   <p:notesSz cx="6858000" cy="9144000"/>
@@ -204,7 +205,7 @@
           <a:p>
             <a:fld id="{495B23F1-5DD4-4F94-83D0-FB21708CEBD2}" type="datetimeFigureOut">
               <a:rPr lang="en-US" smtClean="0"/>
-              <a:t>2/8/2024</a:t>
+              <a:t>2/19/2024</a:t>
             </a:fld>
             <a:endParaRPr lang="en-US"/>
           </a:p>
@@ -566,6 +567,119 @@
 </p:notes>
 </file>
 
+<file path=ppt/notesSlides/notesSlide2.xml><?xml version="1.0" encoding="utf-8"?>
+<p:notes xmlns:a="http://schemas.openxmlformats.org/drawingml/2006/main" xmlns:r="http://schemas.openxmlformats.org/officeDocument/2006/relationships" xmlns:p="http://schemas.openxmlformats.org/presentationml/2006/main">
+  <p:cSld>
+    <p:spTree>
+      <p:nvGrpSpPr>
+        <p:cNvPr id="1" name=""/>
+        <p:cNvGrpSpPr/>
+        <p:nvPr/>
+      </p:nvGrpSpPr>
+      <p:grpSpPr>
+        <a:xfrm>
+          <a:off x="0" y="0"/>
+          <a:ext cx="0" cy="0"/>
+          <a:chOff x="0" y="0"/>
+          <a:chExt cx="0" cy="0"/>
+        </a:xfrm>
+      </p:grpSpPr>
+      <p:sp>
+        <p:nvSpPr>
+          <p:cNvPr id="2" name="Slide Image Placeholder 1"/>
+          <p:cNvSpPr>
+            <a:spLocks noGrp="1" noRot="1" noChangeAspect="1"/>
+          </p:cNvSpPr>
+          <p:nvPr>
+            <p:ph type="sldImg"/>
+          </p:nvPr>
+        </p:nvSpPr>
+        <p:spPr/>
+      </p:sp>
+      <p:sp>
+        <p:nvSpPr>
+          <p:cNvPr id="3" name="Notes Placeholder 2"/>
+          <p:cNvSpPr>
+            <a:spLocks noGrp="1"/>
+          </p:cNvSpPr>
+          <p:nvPr>
+            <p:ph type="body" idx="1"/>
+          </p:nvPr>
+        </p:nvSpPr>
+        <p:spPr/>
+        <p:txBody>
+          <a:bodyPr/>
+          <a:lstStyle/>
+          <a:p>
+            <a:r>
+              <a:rPr lang="en-US" dirty="0"/>
+              <a:t>https://www.sciencedirect.com/science/article/pii/S0893608023003301#b51</a:t>
+            </a:r>
+          </a:p>
+          <a:p>
+            <a:r>
+              <a:rPr lang="en-US" dirty="0"/>
+              <a:t>https://www.sciencedirect.com/science/article/pii/S0925231214005785</a:t>
+            </a:r>
+          </a:p>
+          <a:p>
+            <a:endParaRPr lang="en-US" dirty="0"/>
+          </a:p>
+          <a:p>
+            <a:r>
+              <a:rPr lang="en-US"/>
+              <a:t>Image segmentation:</a:t>
+            </a:r>
+            <a:br>
+              <a:rPr lang="en-US"/>
+            </a:br>
+            <a:r>
+              <a:rPr lang="en-US"/>
+              <a:t>https://ieeexplore.ieee.org/document/9833331</a:t>
+            </a:r>
+            <a:endParaRPr lang="en-US" dirty="0"/>
+          </a:p>
+          <a:p>
+            <a:endParaRPr lang="en-US" dirty="0"/>
+          </a:p>
+        </p:txBody>
+      </p:sp>
+      <p:sp>
+        <p:nvSpPr>
+          <p:cNvPr id="4" name="Slide Number Placeholder 3"/>
+          <p:cNvSpPr>
+            <a:spLocks noGrp="1"/>
+          </p:cNvSpPr>
+          <p:nvPr>
+            <p:ph type="sldNum" sz="quarter" idx="5"/>
+          </p:nvPr>
+        </p:nvSpPr>
+        <p:spPr/>
+        <p:txBody>
+          <a:bodyPr/>
+          <a:lstStyle/>
+          <a:p>
+            <a:fld id="{C6AB73BE-9BB2-4F53-A86A-95202E9EDE46}" type="slidenum">
+              <a:rPr lang="en-US" smtClean="0"/>
+              <a:t>9</a:t>
+            </a:fld>
+            <a:endParaRPr lang="en-US"/>
+          </a:p>
+        </p:txBody>
+      </p:sp>
+    </p:spTree>
+    <p:extLst>
+      <p:ext uri="{BB962C8B-B14F-4D97-AF65-F5344CB8AC3E}">
+        <p14:creationId xmlns:p14="http://schemas.microsoft.com/office/powerpoint/2010/main" val="2982567079"/>
+      </p:ext>
+    </p:extLst>
+  </p:cSld>
+  <p:clrMapOvr>
+    <a:masterClrMapping/>
+  </p:clrMapOvr>
+</p:notes>
+</file>
+
 <file path=ppt/slideLayouts/slideLayout1.xml><?xml version="1.0" encoding="utf-8"?>
 <p:sldLayout xmlns:a="http://schemas.openxmlformats.org/drawingml/2006/main" xmlns:r="http://schemas.openxmlformats.org/officeDocument/2006/relationships" xmlns:p="http://schemas.openxmlformats.org/presentationml/2006/main" type="title" preserve="1">
   <p:cSld name="Title Slide">
@@ -713,7 +827,7 @@
           <a:p>
             <a:fld id="{18514EC9-E150-4B7A-9B8E-2980A974DF62}" type="datetimeFigureOut">
               <a:rPr lang="en-US" smtClean="0"/>
-              <a:t>2/8/2024</a:t>
+              <a:t>2/19/2024</a:t>
             </a:fld>
             <a:endParaRPr lang="en-US"/>
           </a:p>
@@ -911,7 +1025,7 @@
           <a:p>
             <a:fld id="{18514EC9-E150-4B7A-9B8E-2980A974DF62}" type="datetimeFigureOut">
               <a:rPr lang="en-US" smtClean="0"/>
-              <a:t>2/8/2024</a:t>
+              <a:t>2/19/2024</a:t>
             </a:fld>
             <a:endParaRPr lang="en-US"/>
           </a:p>
@@ -1119,7 +1233,7 @@
           <a:p>
             <a:fld id="{18514EC9-E150-4B7A-9B8E-2980A974DF62}" type="datetimeFigureOut">
               <a:rPr lang="en-US" smtClean="0"/>
-              <a:t>2/8/2024</a:t>
+              <a:t>2/19/2024</a:t>
             </a:fld>
             <a:endParaRPr lang="en-US"/>
           </a:p>
@@ -1317,7 +1431,7 @@
           <a:p>
             <a:fld id="{18514EC9-E150-4B7A-9B8E-2980A974DF62}" type="datetimeFigureOut">
               <a:rPr lang="en-US" smtClean="0"/>
-              <a:t>2/8/2024</a:t>
+              <a:t>2/19/2024</a:t>
             </a:fld>
             <a:endParaRPr lang="en-US"/>
           </a:p>
@@ -1592,7 +1706,7 @@
           <a:p>
             <a:fld id="{18514EC9-E150-4B7A-9B8E-2980A974DF62}" type="datetimeFigureOut">
               <a:rPr lang="en-US" smtClean="0"/>
-              <a:t>2/8/2024</a:t>
+              <a:t>2/19/2024</a:t>
             </a:fld>
             <a:endParaRPr lang="en-US"/>
           </a:p>
@@ -1857,7 +1971,7 @@
           <a:p>
             <a:fld id="{18514EC9-E150-4B7A-9B8E-2980A974DF62}" type="datetimeFigureOut">
               <a:rPr lang="en-US" smtClean="0"/>
-              <a:t>2/8/2024</a:t>
+              <a:t>2/19/2024</a:t>
             </a:fld>
             <a:endParaRPr lang="en-US"/>
           </a:p>
@@ -2269,7 +2383,7 @@
           <a:p>
             <a:fld id="{18514EC9-E150-4B7A-9B8E-2980A974DF62}" type="datetimeFigureOut">
               <a:rPr lang="en-US" smtClean="0"/>
-              <a:t>2/8/2024</a:t>
+              <a:t>2/19/2024</a:t>
             </a:fld>
             <a:endParaRPr lang="en-US"/>
           </a:p>
@@ -2410,7 +2524,7 @@
           <a:p>
             <a:fld id="{18514EC9-E150-4B7A-9B8E-2980A974DF62}" type="datetimeFigureOut">
               <a:rPr lang="en-US" smtClean="0"/>
-              <a:t>2/8/2024</a:t>
+              <a:t>2/19/2024</a:t>
             </a:fld>
             <a:endParaRPr lang="en-US"/>
           </a:p>
@@ -2523,7 +2637,7 @@
           <a:p>
             <a:fld id="{18514EC9-E150-4B7A-9B8E-2980A974DF62}" type="datetimeFigureOut">
               <a:rPr lang="en-US" smtClean="0"/>
-              <a:t>2/8/2024</a:t>
+              <a:t>2/19/2024</a:t>
             </a:fld>
             <a:endParaRPr lang="en-US"/>
           </a:p>
@@ -2834,7 +2948,7 @@
           <a:p>
             <a:fld id="{18514EC9-E150-4B7A-9B8E-2980A974DF62}" type="datetimeFigureOut">
               <a:rPr lang="en-US" smtClean="0"/>
-              <a:t>2/8/2024</a:t>
+              <a:t>2/19/2024</a:t>
             </a:fld>
             <a:endParaRPr lang="en-US"/>
           </a:p>
@@ -3122,7 +3236,7 @@
           <a:p>
             <a:fld id="{18514EC9-E150-4B7A-9B8E-2980A974DF62}" type="datetimeFigureOut">
               <a:rPr lang="en-US" smtClean="0"/>
-              <a:t>2/8/2024</a:t>
+              <a:t>2/19/2024</a:t>
             </a:fld>
             <a:endParaRPr lang="en-US"/>
           </a:p>
@@ -3363,7 +3477,7 @@
           <a:p>
             <a:fld id="{18514EC9-E150-4B7A-9B8E-2980A974DF62}" type="datetimeFigureOut">
               <a:rPr lang="en-US" smtClean="0"/>
-              <a:t>2/8/2024</a:t>
+              <a:t>2/19/2024</a:t>
             </a:fld>
             <a:endParaRPr lang="en-US"/>
           </a:p>
@@ -6219,6 +6333,168 @@
     <p:extLst>
       <p:ext uri="{BB962C8B-B14F-4D97-AF65-F5344CB8AC3E}">
         <p14:creationId xmlns:p14="http://schemas.microsoft.com/office/powerpoint/2010/main" val="3329809002"/>
+      </p:ext>
+    </p:extLst>
+  </p:cSld>
+  <p:clrMapOvr>
+    <a:masterClrMapping/>
+  </p:clrMapOvr>
+</p:sld>
+</file>
+
+<file path=ppt/slides/slide9.xml><?xml version="1.0" encoding="utf-8"?>
+<p:sld xmlns:a="http://schemas.openxmlformats.org/drawingml/2006/main" xmlns:r="http://schemas.openxmlformats.org/officeDocument/2006/relationships" xmlns:p="http://schemas.openxmlformats.org/presentationml/2006/main">
+  <p:cSld>
+    <p:spTree>
+      <p:nvGrpSpPr>
+        <p:cNvPr id="1" name=""/>
+        <p:cNvGrpSpPr/>
+        <p:nvPr/>
+      </p:nvGrpSpPr>
+      <p:grpSpPr>
+        <a:xfrm>
+          <a:off x="0" y="0"/>
+          <a:ext cx="0" cy="0"/>
+          <a:chOff x="0" y="0"/>
+          <a:chExt cx="0" cy="0"/>
+        </a:xfrm>
+      </p:grpSpPr>
+      <p:sp>
+        <p:nvSpPr>
+          <p:cNvPr id="2" name="Title 1">
+            <a:extLst>
+              <a:ext uri="{FF2B5EF4-FFF2-40B4-BE49-F238E27FC236}">
+                <a16:creationId xmlns:a16="http://schemas.microsoft.com/office/drawing/2014/main" id="{CF8CC35C-8811-0C0F-DADB-CC5739ECB7CF}"/>
+              </a:ext>
+            </a:extLst>
+          </p:cNvPr>
+          <p:cNvSpPr>
+            <a:spLocks noGrp="1"/>
+          </p:cNvSpPr>
+          <p:nvPr>
+            <p:ph type="title"/>
+          </p:nvPr>
+        </p:nvSpPr>
+        <p:spPr/>
+        <p:txBody>
+          <a:bodyPr/>
+          <a:lstStyle/>
+          <a:p>
+            <a:pPr algn="ctr"/>
+            <a:r>
+              <a:rPr lang="en-US" dirty="0"/>
+              <a:t>STDP for SNNs</a:t>
+            </a:r>
+          </a:p>
+        </p:txBody>
+      </p:sp>
+      <p:sp>
+        <p:nvSpPr>
+          <p:cNvPr id="3" name="Content Placeholder 2">
+            <a:extLst>
+              <a:ext uri="{FF2B5EF4-FFF2-40B4-BE49-F238E27FC236}">
+                <a16:creationId xmlns:a16="http://schemas.microsoft.com/office/drawing/2014/main" id="{79FF6445-2AA8-FFC8-7B3B-2BFBA339114F}"/>
+              </a:ext>
+            </a:extLst>
+          </p:cNvPr>
+          <p:cNvSpPr>
+            <a:spLocks noGrp="1"/>
+          </p:cNvSpPr>
+          <p:nvPr>
+            <p:ph idx="1"/>
+          </p:nvPr>
+        </p:nvSpPr>
+        <p:spPr>
+          <a:xfrm>
+            <a:off x="838200" y="1825625"/>
+            <a:ext cx="5257800" cy="4351338"/>
+          </a:xfrm>
+        </p:spPr>
+        <p:txBody>
+          <a:bodyPr>
+            <a:normAutofit fontScale="92500" lnSpcReduction="20000"/>
+          </a:bodyPr>
+          <a:lstStyle/>
+          <a:p>
+            <a:r>
+              <a:rPr lang="en-US" dirty="0"/>
+              <a:t>Recent unsupervised STDP models able to achieve 98% accuracy on MNIST</a:t>
+            </a:r>
+          </a:p>
+          <a:p>
+            <a:pPr marL="0" indent="0">
+              <a:buNone/>
+            </a:pPr>
+            <a:endParaRPr lang="en-US" dirty="0"/>
+          </a:p>
+          <a:p>
+            <a:r>
+              <a:rPr lang="en-US" dirty="0"/>
+              <a:t>Supervised STDP models can use global feedback without backprop</a:t>
+            </a:r>
+          </a:p>
+          <a:p>
+            <a:pPr lvl="1"/>
+            <a:r>
+              <a:rPr lang="en-US" dirty="0"/>
+              <a:t>Potentially usable for initial training</a:t>
+            </a:r>
+          </a:p>
+          <a:p>
+            <a:pPr marL="457200" lvl="1" indent="0">
+              <a:buNone/>
+            </a:pPr>
+            <a:endParaRPr lang="en-US" dirty="0"/>
+          </a:p>
+          <a:p>
+            <a:r>
+              <a:rPr lang="en-US" dirty="0"/>
+              <a:t>Possible to add more neurons hidden layers based on timing thresholds</a:t>
+            </a:r>
+          </a:p>
+          <a:p>
+            <a:pPr lvl="1"/>
+            <a:r>
+              <a:rPr lang="en-US" dirty="0"/>
+              <a:t>Would this be adjustable to neuromorphic devices?</a:t>
+            </a:r>
+          </a:p>
+        </p:txBody>
+      </p:sp>
+      <p:pic>
+        <p:nvPicPr>
+          <p:cNvPr id="6" name="Picture 5">
+            <a:extLst>
+              <a:ext uri="{FF2B5EF4-FFF2-40B4-BE49-F238E27FC236}">
+                <a16:creationId xmlns:a16="http://schemas.microsoft.com/office/drawing/2014/main" id="{546AD1B3-4716-E358-6CB1-C8C571A986B7}"/>
+              </a:ext>
+            </a:extLst>
+          </p:cNvPr>
+          <p:cNvPicPr>
+            <a:picLocks noChangeAspect="1"/>
+          </p:cNvPicPr>
+          <p:nvPr/>
+        </p:nvPicPr>
+        <p:blipFill>
+          <a:blip r:embed="rId3"/>
+          <a:stretch>
+            <a:fillRect/>
+          </a:stretch>
+        </p:blipFill>
+        <p:spPr>
+          <a:xfrm>
+            <a:off x="6953014" y="2291380"/>
+            <a:ext cx="4400786" cy="3207148"/>
+          </a:xfrm>
+          <a:prstGeom prst="rect">
+            <a:avLst/>
+          </a:prstGeom>
+        </p:spPr>
+      </p:pic>
+    </p:spTree>
+    <p:extLst>
+      <p:ext uri="{BB962C8B-B14F-4D97-AF65-F5344CB8AC3E}">
+        <p14:creationId xmlns:p14="http://schemas.microsoft.com/office/powerpoint/2010/main" val="1131794860"/>
       </p:ext>
     </p:extLst>
   </p:cSld>

</xml_diff>

<commit_message>
Adding pretrained models for binary & trinary class
</commit_message>
<xml_diff>
--- a/SNN.pptx
+++ b/SNN.pptx
@@ -5,7 +5,7 @@
     <p:sldMasterId id="2147483648" r:id="rId1"/>
   </p:sldMasterIdLst>
   <p:notesMasterIdLst>
-    <p:notesMasterId r:id="rId13"/>
+    <p:notesMasterId r:id="rId14"/>
   </p:notesMasterIdLst>
   <p:sldIdLst>
     <p:sldId id="257" r:id="rId2"/>
@@ -19,6 +19,7 @@
     <p:sldId id="266" r:id="rId10"/>
     <p:sldId id="267" r:id="rId11"/>
     <p:sldId id="268" r:id="rId12"/>
+    <p:sldId id="269" r:id="rId13"/>
   </p:sldIdLst>
   <p:sldSz cx="12192000" cy="6858000"/>
   <p:notesSz cx="6858000" cy="9144000"/>
@@ -207,7 +208,7 @@
           <a:p>
             <a:fld id="{495B23F1-5DD4-4F94-83D0-FB21708CEBD2}" type="datetimeFigureOut">
               <a:rPr lang="en-US" smtClean="0"/>
-              <a:t>4/4/2024</a:t>
+              <a:t>4/24/2024</a:t>
             </a:fld>
             <a:endParaRPr lang="en-US"/>
           </a:p>
@@ -930,7 +931,7 @@
           <a:p>
             <a:fld id="{18514EC9-E150-4B7A-9B8E-2980A974DF62}" type="datetimeFigureOut">
               <a:rPr lang="en-US" smtClean="0"/>
-              <a:t>4/4/2024</a:t>
+              <a:t>4/24/2024</a:t>
             </a:fld>
             <a:endParaRPr lang="en-US"/>
           </a:p>
@@ -1128,7 +1129,7 @@
           <a:p>
             <a:fld id="{18514EC9-E150-4B7A-9B8E-2980A974DF62}" type="datetimeFigureOut">
               <a:rPr lang="en-US" smtClean="0"/>
-              <a:t>4/4/2024</a:t>
+              <a:t>4/24/2024</a:t>
             </a:fld>
             <a:endParaRPr lang="en-US"/>
           </a:p>
@@ -1336,7 +1337,7 @@
           <a:p>
             <a:fld id="{18514EC9-E150-4B7A-9B8E-2980A974DF62}" type="datetimeFigureOut">
               <a:rPr lang="en-US" smtClean="0"/>
-              <a:t>4/4/2024</a:t>
+              <a:t>4/24/2024</a:t>
             </a:fld>
             <a:endParaRPr lang="en-US"/>
           </a:p>
@@ -1534,7 +1535,7 @@
           <a:p>
             <a:fld id="{18514EC9-E150-4B7A-9B8E-2980A974DF62}" type="datetimeFigureOut">
               <a:rPr lang="en-US" smtClean="0"/>
-              <a:t>4/4/2024</a:t>
+              <a:t>4/24/2024</a:t>
             </a:fld>
             <a:endParaRPr lang="en-US"/>
           </a:p>
@@ -1809,7 +1810,7 @@
           <a:p>
             <a:fld id="{18514EC9-E150-4B7A-9B8E-2980A974DF62}" type="datetimeFigureOut">
               <a:rPr lang="en-US" smtClean="0"/>
-              <a:t>4/4/2024</a:t>
+              <a:t>4/24/2024</a:t>
             </a:fld>
             <a:endParaRPr lang="en-US"/>
           </a:p>
@@ -2074,7 +2075,7 @@
           <a:p>
             <a:fld id="{18514EC9-E150-4B7A-9B8E-2980A974DF62}" type="datetimeFigureOut">
               <a:rPr lang="en-US" smtClean="0"/>
-              <a:t>4/4/2024</a:t>
+              <a:t>4/24/2024</a:t>
             </a:fld>
             <a:endParaRPr lang="en-US"/>
           </a:p>
@@ -2486,7 +2487,7 @@
           <a:p>
             <a:fld id="{18514EC9-E150-4B7A-9B8E-2980A974DF62}" type="datetimeFigureOut">
               <a:rPr lang="en-US" smtClean="0"/>
-              <a:t>4/4/2024</a:t>
+              <a:t>4/24/2024</a:t>
             </a:fld>
             <a:endParaRPr lang="en-US"/>
           </a:p>
@@ -2627,7 +2628,7 @@
           <a:p>
             <a:fld id="{18514EC9-E150-4B7A-9B8E-2980A974DF62}" type="datetimeFigureOut">
               <a:rPr lang="en-US" smtClean="0"/>
-              <a:t>4/4/2024</a:t>
+              <a:t>4/24/2024</a:t>
             </a:fld>
             <a:endParaRPr lang="en-US"/>
           </a:p>
@@ -2740,7 +2741,7 @@
           <a:p>
             <a:fld id="{18514EC9-E150-4B7A-9B8E-2980A974DF62}" type="datetimeFigureOut">
               <a:rPr lang="en-US" smtClean="0"/>
-              <a:t>4/4/2024</a:t>
+              <a:t>4/24/2024</a:t>
             </a:fld>
             <a:endParaRPr lang="en-US"/>
           </a:p>
@@ -3051,7 +3052,7 @@
           <a:p>
             <a:fld id="{18514EC9-E150-4B7A-9B8E-2980A974DF62}" type="datetimeFigureOut">
               <a:rPr lang="en-US" smtClean="0"/>
-              <a:t>4/4/2024</a:t>
+              <a:t>4/24/2024</a:t>
             </a:fld>
             <a:endParaRPr lang="en-US"/>
           </a:p>
@@ -3339,7 +3340,7 @@
           <a:p>
             <a:fld id="{18514EC9-E150-4B7A-9B8E-2980A974DF62}" type="datetimeFigureOut">
               <a:rPr lang="en-US" smtClean="0"/>
-              <a:t>4/4/2024</a:t>
+              <a:t>4/24/2024</a:t>
             </a:fld>
             <a:endParaRPr lang="en-US"/>
           </a:p>
@@ -3580,7 +3581,7 @@
           <a:p>
             <a:fld id="{18514EC9-E150-4B7A-9B8E-2980A974DF62}" type="datetimeFigureOut">
               <a:rPr lang="en-US" smtClean="0"/>
-              <a:t>4/4/2024</a:t>
+              <a:t>4/24/2024</a:t>
             </a:fld>
             <a:endParaRPr lang="en-US"/>
           </a:p>
@@ -4784,6 +4785,146 @@
     <p:extLst>
       <p:ext uri="{BB962C8B-B14F-4D97-AF65-F5344CB8AC3E}">
         <p14:creationId xmlns:p14="http://schemas.microsoft.com/office/powerpoint/2010/main" val="1656334707"/>
+      </p:ext>
+    </p:extLst>
+  </p:cSld>
+  <p:clrMapOvr>
+    <a:masterClrMapping/>
+  </p:clrMapOvr>
+</p:sld>
+</file>
+
+<file path=ppt/slides/slide12.xml><?xml version="1.0" encoding="utf-8"?>
+<p:sld xmlns:a="http://schemas.openxmlformats.org/drawingml/2006/main" xmlns:r="http://schemas.openxmlformats.org/officeDocument/2006/relationships" xmlns:p="http://schemas.openxmlformats.org/presentationml/2006/main">
+  <p:cSld>
+    <p:spTree>
+      <p:nvGrpSpPr>
+        <p:cNvPr id="1" name=""/>
+        <p:cNvGrpSpPr/>
+        <p:nvPr/>
+      </p:nvGrpSpPr>
+      <p:grpSpPr>
+        <a:xfrm>
+          <a:off x="0" y="0"/>
+          <a:ext cx="0" cy="0"/>
+          <a:chOff x="0" y="0"/>
+          <a:chExt cx="0" cy="0"/>
+        </a:xfrm>
+      </p:grpSpPr>
+      <p:sp>
+        <p:nvSpPr>
+          <p:cNvPr id="2" name="Title 1">
+            <a:extLst>
+              <a:ext uri="{FF2B5EF4-FFF2-40B4-BE49-F238E27FC236}">
+                <a16:creationId xmlns:a16="http://schemas.microsoft.com/office/drawing/2014/main" id="{77B4C55D-E2DD-4A77-9517-2142511EAA6F}"/>
+              </a:ext>
+            </a:extLst>
+          </p:cNvPr>
+          <p:cNvSpPr>
+            <a:spLocks noGrp="1"/>
+          </p:cNvSpPr>
+          <p:nvPr>
+            <p:ph type="title"/>
+          </p:nvPr>
+        </p:nvSpPr>
+        <p:spPr/>
+        <p:txBody>
+          <a:bodyPr/>
+          <a:lstStyle/>
+          <a:p>
+            <a:endParaRPr lang="en-US"/>
+          </a:p>
+        </p:txBody>
+      </p:sp>
+      <p:sp>
+        <p:nvSpPr>
+          <p:cNvPr id="3" name="Content Placeholder 2">
+            <a:extLst>
+              <a:ext uri="{FF2B5EF4-FFF2-40B4-BE49-F238E27FC236}">
+                <a16:creationId xmlns:a16="http://schemas.microsoft.com/office/drawing/2014/main" id="{4269AEB0-648E-B638-9F8B-A1BD565FBD9E}"/>
+              </a:ext>
+            </a:extLst>
+          </p:cNvPr>
+          <p:cNvSpPr>
+            <a:spLocks noGrp="1"/>
+          </p:cNvSpPr>
+          <p:nvPr>
+            <p:ph idx="1"/>
+          </p:nvPr>
+        </p:nvSpPr>
+        <p:spPr/>
+        <p:txBody>
+          <a:bodyPr/>
+          <a:lstStyle/>
+          <a:p>
+            <a:endParaRPr lang="en-US" dirty="0"/>
+          </a:p>
+        </p:txBody>
+      </p:sp>
+      <p:pic>
+        <p:nvPicPr>
+          <p:cNvPr id="9" name="Picture 8">
+            <a:extLst>
+              <a:ext uri="{FF2B5EF4-FFF2-40B4-BE49-F238E27FC236}">
+                <a16:creationId xmlns:a16="http://schemas.microsoft.com/office/drawing/2014/main" id="{A8F61FD3-2602-9AD7-6C77-2836B9C05651}"/>
+              </a:ext>
+            </a:extLst>
+          </p:cNvPr>
+          <p:cNvPicPr>
+            <a:picLocks noChangeAspect="1"/>
+          </p:cNvPicPr>
+          <p:nvPr/>
+        </p:nvPicPr>
+        <p:blipFill>
+          <a:blip r:embed="rId2"/>
+          <a:stretch>
+            <a:fillRect/>
+          </a:stretch>
+        </p:blipFill>
+        <p:spPr>
+          <a:xfrm>
+            <a:off x="6285793" y="1154842"/>
+            <a:ext cx="5068007" cy="4601217"/>
+          </a:xfrm>
+          <a:prstGeom prst="rect">
+            <a:avLst/>
+          </a:prstGeom>
+        </p:spPr>
+      </p:pic>
+      <p:pic>
+        <p:nvPicPr>
+          <p:cNvPr id="11" name="Picture 10">
+            <a:extLst>
+              <a:ext uri="{FF2B5EF4-FFF2-40B4-BE49-F238E27FC236}">
+                <a16:creationId xmlns:a16="http://schemas.microsoft.com/office/drawing/2014/main" id="{44C493DE-9AE3-F05A-1C08-BF1EE2CBF1F3}"/>
+              </a:ext>
+            </a:extLst>
+          </p:cNvPr>
+          <p:cNvPicPr>
+            <a:picLocks noChangeAspect="1"/>
+          </p:cNvPicPr>
+          <p:nvPr/>
+        </p:nvPicPr>
+        <p:blipFill>
+          <a:blip r:embed="rId3"/>
+          <a:stretch>
+            <a:fillRect/>
+          </a:stretch>
+        </p:blipFill>
+        <p:spPr>
+          <a:xfrm>
+            <a:off x="980440" y="1825625"/>
+            <a:ext cx="4544539" cy="4084003"/>
+          </a:xfrm>
+          <a:prstGeom prst="rect">
+            <a:avLst/>
+          </a:prstGeom>
+        </p:spPr>
+      </p:pic>
+    </p:spTree>
+    <p:extLst>
+      <p:ext uri="{BB962C8B-B14F-4D97-AF65-F5344CB8AC3E}">
+        <p14:creationId xmlns:p14="http://schemas.microsoft.com/office/powerpoint/2010/main" val="3463958083"/>
       </p:ext>
     </p:extLst>
   </p:cSld>

</xml_diff>